<commit_message>
W02/D5: Kahoot, day sheet and lab note, provenance, take-home and self-check, board work, pre-read, extras
The afternoon deck's close no longer quotes Dr Priya Menon, since no locked source gives her words.

Co-Authored-By: Claude Opus 5.5 <noreply@anthropic.com>
Claude-Session: https://claude.ai/code/session_01123CnpKxdZ7Th4XwviT5bS
</commit_message>
<xml_diff>
--- a/content/W02/D5/slides/C2_W02_D05_half2_STUDENT.pptx
+++ b/content/W02/D5/slides/C2_W02_D05_half2_STUDENT.pptx
@@ -19991,109 +19991,52 @@
       </p:sp>
       <p:sp>
         <p:nvSpPr>
-          <p:cNvPr id="9" name="Rounded Rectangle 8"/>
+          <p:cNvPr id="9" name="TextBox 8"/>
+          <p:cNvSpPr txBox="1"/>
+          <p:nvPr/>
+        </p:nvSpPr>
+        <p:spPr>
+          <a:xfrm>
+            <a:off x="530352" y="1956816"/>
+            <a:ext cx="11130991" cy="772160"/>
+          </a:xfrm>
+          <a:prstGeom prst="rect">
+            <a:avLst/>
+          </a:prstGeom>
+          <a:noFill/>
+        </p:spPr>
+        <p:txBody>
+          <a:bodyPr wrap="square" anchor="t" lIns="0" rIns="0" tIns="0" bIns="0">
+            <a:spAutoFit/>
+          </a:bodyPr>
+          <a:lstStyle/>
+          <a:p>
+            <a:pPr>
+              <a:spcAft>
+                <a:spcPts val="800"/>
+              </a:spcAft>
+            </a:pPr>
+            <a:r>
+              <a:rPr sz="1600" b="0" i="0">
+                <a:solidFill>
+                  <a:srgbClr val="1A1440"/>
+                </a:solidFill>
+                <a:latin typeface="Calibri"/>
+              </a:rPr>
+              <a:t>Dr Priya Menon, COO of Kalpa Health, brings Meera's question to a diagnostics business that grew 5 percent against a plan of 18.</a:t>
+            </a:r>
+          </a:p>
+        </p:txBody>
+      </p:sp>
+      <p:sp>
+        <p:nvSpPr>
+          <p:cNvPr id="10" name="Rounded Rectangle 9"/>
           <p:cNvSpPr/>
           <p:nvPr/>
         </p:nvSpPr>
         <p:spPr>
           <a:xfrm>
-            <a:off x="530352" y="1956816"/>
-            <a:ext cx="45720" cy="741680"/>
-          </a:xfrm>
-          <a:prstGeom prst="roundRect">
-            <a:avLst>
-              <a:gd name="adj" fmla="val 50000"/>
-            </a:avLst>
-          </a:prstGeom>
-          <a:solidFill>
-            <a:srgbClr val="D9A7FF"/>
-          </a:solidFill>
-          <a:ln>
-            <a:noFill/>
-          </a:ln>
-          <a:effectLst/>
-        </p:spPr>
-        <p:style>
-          <a:lnRef idx="1">
-            <a:schemeClr val="accent1"/>
-          </a:lnRef>
-          <a:fillRef idx="3">
-            <a:schemeClr val="accent1"/>
-          </a:fillRef>
-          <a:effectRef idx="2">
-            <a:schemeClr val="accent1"/>
-          </a:effectRef>
-          <a:fontRef idx="minor">
-            <a:schemeClr val="lt1"/>
-          </a:fontRef>
-        </p:style>
-        <p:txBody>
-          <a:bodyPr rtlCol="0" anchor="ctr" wrap="square"/>
-          <a:lstStyle/>
-          <a:p>
-            <a:pPr algn="ctr"/>
-          </a:p>
-        </p:txBody>
-      </p:sp>
-      <p:sp>
-        <p:nvSpPr>
-          <p:cNvPr id="10" name="TextBox 9"/>
-          <p:cNvSpPr txBox="1"/>
-          <p:nvPr/>
-        </p:nvSpPr>
-        <p:spPr>
-          <a:xfrm>
-            <a:off x="786384" y="1956816"/>
-            <a:ext cx="10820095" cy="741680"/>
-          </a:xfrm>
-          <a:prstGeom prst="rect">
-            <a:avLst/>
-          </a:prstGeom>
-          <a:noFill/>
-        </p:spPr>
-        <p:txBody>
-          <a:bodyPr wrap="square" anchor="t" lIns="0" rIns="0" tIns="0" bIns="0">
-            <a:spAutoFit/>
-          </a:bodyPr>
-          <a:lstStyle/>
-          <a:p>
-            <a:r>
-              <a:rPr sz="1600" b="0" i="1">
-                <a:solidFill>
-                  <a:srgbClr val="1A0F5C"/>
-                </a:solidFill>
-                <a:latin typeface="Georgia"/>
-              </a:rPr>
-              <a:t>"Where does our growth come from?"</a:t>
-            </a:r>
-          </a:p>
-          <a:p>
-            <a:pPr>
-              <a:spcBef>
-                <a:spcPts val="400"/>
-              </a:spcBef>
-            </a:pPr>
-            <a:r>
-              <a:rPr sz="1000" b="0" i="0">
-                <a:solidFill>
-                  <a:srgbClr val="6B6690"/>
-                </a:solidFill>
-                <a:latin typeface="Calibri"/>
-              </a:rPr>
-              <a:t>Dr Priya Menon, COO, Kalpa Health, whose diagnostics business grew 5 percent against a plan of 18</a:t>
-            </a:r>
-          </a:p>
-        </p:txBody>
-      </p:sp>
-      <p:sp>
-        <p:nvSpPr>
-          <p:cNvPr id="11" name="Rounded Rectangle 10"/>
-          <p:cNvSpPr/>
-          <p:nvPr/>
-        </p:nvSpPr>
-        <p:spPr>
-          <a:xfrm>
-            <a:off x="530352" y="2844800"/>
+            <a:off x="530352" y="2856992"/>
             <a:ext cx="3588410" cy="1964436"/>
           </a:xfrm>
           <a:prstGeom prst="roundRect">
@@ -20141,13 +20084,13 @@
       </p:sp>
       <p:sp>
         <p:nvSpPr>
-          <p:cNvPr id="12" name="Oval 11"/>
+          <p:cNvPr id="11" name="Oval 10"/>
           <p:cNvSpPr/>
           <p:nvPr/>
         </p:nvSpPr>
         <p:spPr>
           <a:xfrm>
-            <a:off x="731519" y="3045968"/>
+            <a:off x="731519" y="3058160"/>
             <a:ext cx="457200" cy="457200"/>
           </a:xfrm>
           <a:prstGeom prst="ellipse">
@@ -20185,7 +20128,7 @@
       </p:sp>
       <p:pic>
         <p:nvPicPr>
-          <p:cNvPr id="13" name="Picture 12" descr="flask-conical_7f5aa1048f78.png"/>
+          <p:cNvPr id="12" name="Picture 11" descr="flask-conical_7f5aa1048f78.png"/>
           <p:cNvPicPr>
             <a:picLocks noChangeAspect="1"/>
           </p:cNvPicPr>
@@ -20199,7 +20142,7 @@
         </p:blipFill>
         <p:spPr>
           <a:xfrm>
-            <a:off x="841247" y="3155696"/>
+            <a:off x="841247" y="3167888"/>
             <a:ext cx="237744" cy="237744"/>
           </a:xfrm>
           <a:prstGeom prst="rect">
@@ -20209,14 +20152,49 @@
       </p:pic>
       <p:sp>
         <p:nvSpPr>
+          <p:cNvPr id="13" name="TextBox 12"/>
+          <p:cNvSpPr txBox="1"/>
+          <p:nvPr/>
+        </p:nvSpPr>
+        <p:spPr>
+          <a:xfrm>
+            <a:off x="731519" y="3625088"/>
+            <a:ext cx="3186074" cy="160401"/>
+          </a:xfrm>
+          <a:prstGeom prst="rect">
+            <a:avLst/>
+          </a:prstGeom>
+          <a:noFill/>
+        </p:spPr>
+        <p:txBody>
+          <a:bodyPr wrap="square" anchor="t" lIns="0" rIns="0" tIns="0" bIns="0">
+            <a:spAutoFit/>
+          </a:bodyPr>
+          <a:lstStyle/>
+          <a:p>
+            <a:pPr algn="l"/>
+            <a:r>
+              <a:rPr sz="750" b="1" i="0" spc="250">
+                <a:solidFill>
+                  <a:srgbClr val="5B3FD6"/>
+                </a:solidFill>
+                <a:latin typeface="Calibri"/>
+              </a:rPr>
+              <a:t>WHAT STAYS</a:t>
+            </a:r>
+          </a:p>
+        </p:txBody>
+      </p:sp>
+      <p:sp>
+        <p:nvSpPr>
           <p:cNvPr id="14" name="TextBox 13"/>
           <p:cNvSpPr txBox="1"/>
           <p:nvPr/>
         </p:nvSpPr>
         <p:spPr>
           <a:xfrm>
-            <a:off x="731519" y="3612896"/>
-            <a:ext cx="3186074" cy="160401"/>
+            <a:off x="731519" y="3862832"/>
+            <a:ext cx="3186074" cy="267716"/>
           </a:xfrm>
           <a:prstGeom prst="rect">
             <a:avLst/>
@@ -20231,13 +20209,13 @@
           <a:p>
             <a:pPr algn="l"/>
             <a:r>
-              <a:rPr sz="750" b="1" i="0" spc="250">
-                <a:solidFill>
-                  <a:srgbClr val="5B3FD6"/>
-                </a:solidFill>
-                <a:latin typeface="Calibri"/>
-              </a:rPr>
-              <a:t>WHAT STAYS</a:t>
+              <a:rPr sz="1400" b="1" i="0">
+                <a:solidFill>
+                  <a:srgbClr val="1A0F5C"/>
+                </a:solidFill>
+                <a:latin typeface="Calibri"/>
+              </a:rPr>
+              <a:t>The method</a:t>
             </a:r>
           </a:p>
         </p:txBody>
@@ -20250,8 +20228,8 @@
         </p:nvSpPr>
         <p:spPr>
           <a:xfrm>
-            <a:off x="731519" y="3850640"/>
-            <a:ext cx="3186074" cy="267716"/>
+            <a:off x="731519" y="4203700"/>
+            <a:ext cx="3186074" cy="399796"/>
           </a:xfrm>
           <a:prstGeom prst="rect">
             <a:avLst/>
@@ -20266,41 +20244,6 @@
           <a:p>
             <a:pPr algn="l"/>
             <a:r>
-              <a:rPr sz="1400" b="1" i="0">
-                <a:solidFill>
-                  <a:srgbClr val="1A0F5C"/>
-                </a:solidFill>
-                <a:latin typeface="Calibri"/>
-              </a:rPr>
-              <a:t>The method</a:t>
-            </a:r>
-          </a:p>
-        </p:txBody>
-      </p:sp>
-      <p:sp>
-        <p:nvSpPr>
-          <p:cNvPr id="16" name="TextBox 15"/>
-          <p:cNvSpPr txBox="1"/>
-          <p:nvPr/>
-        </p:nvSpPr>
-        <p:spPr>
-          <a:xfrm>
-            <a:off x="731519" y="4191508"/>
-            <a:ext cx="3186074" cy="399796"/>
-          </a:xfrm>
-          <a:prstGeom prst="rect">
-            <a:avLst/>
-          </a:prstGeom>
-          <a:noFill/>
-        </p:spPr>
-        <p:txBody>
-          <a:bodyPr wrap="square" anchor="t" lIns="0" rIns="0" tIns="0" bIns="0">
-            <a:spAutoFit/>
-          </a:bodyPr>
-          <a:lstStyle/>
-          <a:p>
-            <a:pPr algn="l"/>
-            <a:r>
               <a:rPr sz="1100" b="0" i="0">
                 <a:solidFill>
                   <a:srgbClr val="6B6690"/>
@@ -20314,13 +20257,13 @@
       </p:sp>
       <p:sp>
         <p:nvSpPr>
-          <p:cNvPr id="17" name="Rounded Rectangle 16"/>
+          <p:cNvPr id="16" name="Rounded Rectangle 15"/>
           <p:cNvSpPr/>
           <p:nvPr/>
         </p:nvSpPr>
         <p:spPr>
           <a:xfrm>
-            <a:off x="4301642" y="2844800"/>
+            <a:off x="4301642" y="2856992"/>
             <a:ext cx="3588410" cy="1964436"/>
           </a:xfrm>
           <a:prstGeom prst="roundRect">
@@ -20368,13 +20311,13 @@
       </p:sp>
       <p:sp>
         <p:nvSpPr>
-          <p:cNvPr id="18" name="Oval 17"/>
+          <p:cNvPr id="17" name="Oval 16"/>
           <p:cNvSpPr/>
           <p:nvPr/>
         </p:nvSpPr>
         <p:spPr>
           <a:xfrm>
-            <a:off x="4502810" y="3045968"/>
+            <a:off x="4502810" y="3058160"/>
             <a:ext cx="457200" cy="457200"/>
           </a:xfrm>
           <a:prstGeom prst="ellipse">
@@ -20412,7 +20355,7 @@
       </p:sp>
       <p:pic>
         <p:nvPicPr>
-          <p:cNvPr id="19" name="Picture 18" descr="hospital_8adfcd515209.png"/>
+          <p:cNvPr id="18" name="Picture 17" descr="hospital_8adfcd515209.png"/>
           <p:cNvPicPr>
             <a:picLocks noChangeAspect="1"/>
           </p:cNvPicPr>
@@ -20426,7 +20369,7 @@
         </p:blipFill>
         <p:spPr>
           <a:xfrm>
-            <a:off x="4612538" y="3155696"/>
+            <a:off x="4612538" y="3167888"/>
             <a:ext cx="237744" cy="237744"/>
           </a:xfrm>
           <a:prstGeom prst="rect">
@@ -20436,14 +20379,49 @@
       </p:pic>
       <p:sp>
         <p:nvSpPr>
+          <p:cNvPr id="19" name="TextBox 18"/>
+          <p:cNvSpPr txBox="1"/>
+          <p:nvPr/>
+        </p:nvSpPr>
+        <p:spPr>
+          <a:xfrm>
+            <a:off x="4502810" y="3625088"/>
+            <a:ext cx="3186074" cy="160401"/>
+          </a:xfrm>
+          <a:prstGeom prst="rect">
+            <a:avLst/>
+          </a:prstGeom>
+          <a:noFill/>
+        </p:spPr>
+        <p:txBody>
+          <a:bodyPr wrap="square" anchor="t" lIns="0" rIns="0" tIns="0" bIns="0">
+            <a:spAutoFit/>
+          </a:bodyPr>
+          <a:lstStyle/>
+          <a:p>
+            <a:pPr algn="l"/>
+            <a:r>
+              <a:rPr sz="750" b="1" i="0" spc="250">
+                <a:solidFill>
+                  <a:srgbClr val="5B3FD6"/>
+                </a:solidFill>
+                <a:latin typeface="Calibri"/>
+              </a:rPr>
+              <a:t>WHAT CHANGES</a:t>
+            </a:r>
+          </a:p>
+        </p:txBody>
+      </p:sp>
+      <p:sp>
+        <p:nvSpPr>
           <p:cNvPr id="20" name="TextBox 19"/>
           <p:cNvSpPr txBox="1"/>
           <p:nvPr/>
         </p:nvSpPr>
         <p:spPr>
           <a:xfrm>
-            <a:off x="4502810" y="3612896"/>
-            <a:ext cx="3186074" cy="160401"/>
+            <a:off x="4502810" y="3862832"/>
+            <a:ext cx="3186074" cy="267716"/>
           </a:xfrm>
           <a:prstGeom prst="rect">
             <a:avLst/>
@@ -20458,13 +20436,13 @@
           <a:p>
             <a:pPr algn="l"/>
             <a:r>
-              <a:rPr sz="750" b="1" i="0" spc="250">
-                <a:solidFill>
-                  <a:srgbClr val="5B3FD6"/>
-                </a:solidFill>
-                <a:latin typeface="Calibri"/>
-              </a:rPr>
-              <a:t>WHAT CHANGES</a:t>
+              <a:rPr sz="1400" b="1" i="0">
+                <a:solidFill>
+                  <a:srgbClr val="1A0F5C"/>
+                </a:solidFill>
+                <a:latin typeface="Calibri"/>
+              </a:rPr>
+              <a:t>The domain</a:t>
             </a:r>
           </a:p>
         </p:txBody>
@@ -20477,8 +20455,8 @@
         </p:nvSpPr>
         <p:spPr>
           <a:xfrm>
-            <a:off x="4502810" y="3850640"/>
-            <a:ext cx="3186074" cy="267716"/>
+            <a:off x="4502810" y="4203700"/>
+            <a:ext cx="3186074" cy="399796"/>
           </a:xfrm>
           <a:prstGeom prst="rect">
             <a:avLst/>
@@ -20493,41 +20471,6 @@
           <a:p>
             <a:pPr algn="l"/>
             <a:r>
-              <a:rPr sz="1400" b="1" i="0">
-                <a:solidFill>
-                  <a:srgbClr val="1A0F5C"/>
-                </a:solidFill>
-                <a:latin typeface="Calibri"/>
-              </a:rPr>
-              <a:t>The domain</a:t>
-            </a:r>
-          </a:p>
-        </p:txBody>
-      </p:sp>
-      <p:sp>
-        <p:nvSpPr>
-          <p:cNvPr id="22" name="TextBox 21"/>
-          <p:cNvSpPr txBox="1"/>
-          <p:nvPr/>
-        </p:nvSpPr>
-        <p:spPr>
-          <a:xfrm>
-            <a:off x="4502810" y="4191508"/>
-            <a:ext cx="3186074" cy="399796"/>
-          </a:xfrm>
-          <a:prstGeom prst="rect">
-            <a:avLst/>
-          </a:prstGeom>
-          <a:noFill/>
-        </p:spPr>
-        <p:txBody>
-          <a:bodyPr wrap="square" anchor="t" lIns="0" rIns="0" tIns="0" bIns="0">
-            <a:spAutoFit/>
-          </a:bodyPr>
-          <a:lstStyle/>
-          <a:p>
-            <a:pPr algn="l"/>
-            <a:r>
               <a:rPr sz="1100" b="0" i="0">
                 <a:solidFill>
                   <a:srgbClr val="6B6690"/>
@@ -20541,13 +20484,13 @@
       </p:sp>
       <p:sp>
         <p:nvSpPr>
-          <p:cNvPr id="23" name="Rounded Rectangle 22"/>
+          <p:cNvPr id="22" name="Rounded Rectangle 21"/>
           <p:cNvSpPr/>
           <p:nvPr/>
         </p:nvSpPr>
         <p:spPr>
           <a:xfrm>
-            <a:off x="8072932" y="2844800"/>
+            <a:off x="8072932" y="2856992"/>
             <a:ext cx="3588410" cy="1964436"/>
           </a:xfrm>
           <a:prstGeom prst="roundRect">
@@ -20601,13 +20544,13 @@
       </p:sp>
       <p:sp>
         <p:nvSpPr>
-          <p:cNvPr id="24" name="Oval 23"/>
+          <p:cNvPr id="23" name="Oval 22"/>
           <p:cNvSpPr/>
           <p:nvPr/>
         </p:nvSpPr>
         <p:spPr>
           <a:xfrm>
-            <a:off x="8274100" y="3045968"/>
+            <a:off x="8274100" y="3058160"/>
             <a:ext cx="457200" cy="457200"/>
           </a:xfrm>
           <a:prstGeom prst="ellipse">
@@ -20645,7 +20588,7 @@
       </p:sp>
       <p:pic>
         <p:nvPicPr>
-          <p:cNvPr id="25" name="Picture 24" descr="circle-help_e970ab2886cf.png"/>
+          <p:cNvPr id="24" name="Picture 23" descr="circle-help_e970ab2886cf.png"/>
           <p:cNvPicPr>
             <a:picLocks noChangeAspect="1"/>
           </p:cNvPicPr>
@@ -20659,7 +20602,7 @@
         </p:blipFill>
         <p:spPr>
           <a:xfrm>
-            <a:off x="8383828" y="3155696"/>
+            <a:off x="8383828" y="3167888"/>
             <a:ext cx="237744" cy="237744"/>
           </a:xfrm>
           <a:prstGeom prst="rect">
@@ -20669,14 +20612,49 @@
       </p:pic>
       <p:sp>
         <p:nvSpPr>
+          <p:cNvPr id="25" name="TextBox 24"/>
+          <p:cNvSpPr txBox="1"/>
+          <p:nvPr/>
+        </p:nvSpPr>
+        <p:spPr>
+          <a:xfrm>
+            <a:off x="8274100" y="3625088"/>
+            <a:ext cx="3186074" cy="160401"/>
+          </a:xfrm>
+          <a:prstGeom prst="rect">
+            <a:avLst/>
+          </a:prstGeom>
+          <a:noFill/>
+        </p:spPr>
+        <p:txBody>
+          <a:bodyPr wrap="square" anchor="t" lIns="0" rIns="0" tIns="0" bIns="0">
+            <a:spAutoFit/>
+          </a:bodyPr>
+          <a:lstStyle/>
+          <a:p>
+            <a:pPr algn="l"/>
+            <a:r>
+              <a:rPr sz="750" b="1" i="0" spc="250">
+                <a:solidFill>
+                  <a:srgbClr val="D9A7FF"/>
+                </a:solidFill>
+                <a:latin typeface="Calibri"/>
+              </a:rPr>
+              <a:t>LEFT OPEN</a:t>
+            </a:r>
+          </a:p>
+        </p:txBody>
+      </p:sp>
+      <p:sp>
+        <p:nvSpPr>
           <p:cNvPr id="26" name="TextBox 25"/>
           <p:cNvSpPr txBox="1"/>
           <p:nvPr/>
         </p:nvSpPr>
         <p:spPr>
           <a:xfrm>
-            <a:off x="8274100" y="3612896"/>
-            <a:ext cx="3186074" cy="160401"/>
+            <a:off x="8274100" y="3862832"/>
+            <a:ext cx="3186074" cy="267716"/>
           </a:xfrm>
           <a:prstGeom prst="rect">
             <a:avLst/>
@@ -20691,13 +20669,13 @@
           <a:p>
             <a:pPr algn="l"/>
             <a:r>
-              <a:rPr sz="750" b="1" i="0" spc="250">
-                <a:solidFill>
-                  <a:srgbClr val="D9A7FF"/>
-                </a:solidFill>
-                <a:latin typeface="Calibri"/>
-              </a:rPr>
-              <a:t>LEFT OPEN</a:t>
+              <a:rPr sz="1400" b="1" i="0">
+                <a:solidFill>
+                  <a:srgbClr val="FFFFFF"/>
+                </a:solidFill>
+                <a:latin typeface="Calibri"/>
+              </a:rPr>
+              <a:t>Monday's question</a:t>
             </a:r>
           </a:p>
         </p:txBody>
@@ -20710,8 +20688,8 @@
         </p:nvSpPr>
         <p:spPr>
           <a:xfrm>
-            <a:off x="8274100" y="3850640"/>
-            <a:ext cx="3186074" cy="267716"/>
+            <a:off x="8274100" y="4203700"/>
+            <a:ext cx="3186074" cy="399796"/>
           </a:xfrm>
           <a:prstGeom prst="rect">
             <a:avLst/>
@@ -20726,41 +20704,6 @@
           <a:p>
             <a:pPr algn="l"/>
             <a:r>
-              <a:rPr sz="1400" b="1" i="0">
-                <a:solidFill>
-                  <a:srgbClr val="FFFFFF"/>
-                </a:solidFill>
-                <a:latin typeface="Calibri"/>
-              </a:rPr>
-              <a:t>Monday's question</a:t>
-            </a:r>
-          </a:p>
-        </p:txBody>
-      </p:sp>
-      <p:sp>
-        <p:nvSpPr>
-          <p:cNvPr id="28" name="TextBox 27"/>
-          <p:cNvSpPr txBox="1"/>
-          <p:nvPr/>
-        </p:nvSpPr>
-        <p:spPr>
-          <a:xfrm>
-            <a:off x="8274100" y="4191508"/>
-            <a:ext cx="3186074" cy="399796"/>
-          </a:xfrm>
-          <a:prstGeom prst="rect">
-            <a:avLst/>
-          </a:prstGeom>
-          <a:noFill/>
-        </p:spPr>
-        <p:txBody>
-          <a:bodyPr wrap="square" anchor="t" lIns="0" rIns="0" tIns="0" bIns="0">
-            <a:spAutoFit/>
-          </a:bodyPr>
-          <a:lstStyle/>
-          <a:p>
-            <a:pPr algn="l"/>
-            <a:r>
               <a:rPr sz="1100" b="0" i="0">
                 <a:solidFill>
                   <a:srgbClr val="CFC9EE"/>
@@ -20774,7 +20717,7 @@
       </p:sp>
       <p:sp>
         <p:nvSpPr>
-          <p:cNvPr id="29" name="Oval 28"/>
+          <p:cNvPr id="28" name="Oval 27"/>
           <p:cNvSpPr/>
           <p:nvPr/>
         </p:nvSpPr>
@@ -20818,7 +20761,7 @@
       </p:sp>
       <p:sp>
         <p:nvSpPr>
-          <p:cNvPr id="30" name="TextBox 29"/>
+          <p:cNvPr id="29" name="TextBox 28"/>
           <p:cNvSpPr txBox="1"/>
           <p:nvPr/>
         </p:nvSpPr>
@@ -20853,7 +20796,7 @@
       </p:sp>
       <p:sp>
         <p:nvSpPr>
-          <p:cNvPr id="31" name="Oval 30"/>
+          <p:cNvPr id="30" name="Oval 29"/>
           <p:cNvSpPr/>
           <p:nvPr/>
         </p:nvSpPr>
@@ -20897,7 +20840,7 @@
       </p:sp>
       <p:sp>
         <p:nvSpPr>
-          <p:cNvPr id="32" name="TextBox 31"/>
+          <p:cNvPr id="31" name="TextBox 30"/>
           <p:cNvSpPr txBox="1"/>
           <p:nvPr/>
         </p:nvSpPr>
@@ -20932,7 +20875,7 @@
       </p:sp>
       <p:sp>
         <p:nvSpPr>
-          <p:cNvPr id="33" name="Oval 32"/>
+          <p:cNvPr id="32" name="Oval 31"/>
           <p:cNvSpPr/>
           <p:nvPr/>
         </p:nvSpPr>
@@ -20976,7 +20919,7 @@
       </p:sp>
       <p:sp>
         <p:nvSpPr>
-          <p:cNvPr id="34" name="TextBox 33"/>
+          <p:cNvPr id="33" name="TextBox 32"/>
           <p:cNvSpPr txBox="1"/>
           <p:nvPr/>
         </p:nvSpPr>
@@ -21011,7 +20954,7 @@
       </p:sp>
       <p:sp>
         <p:nvSpPr>
-          <p:cNvPr id="35" name="Oval 34"/>
+          <p:cNvPr id="34" name="Oval 33"/>
           <p:cNvSpPr/>
           <p:nvPr/>
         </p:nvSpPr>
@@ -21055,7 +20998,7 @@
       </p:sp>
       <p:sp>
         <p:nvSpPr>
-          <p:cNvPr id="36" name="TextBox 35"/>
+          <p:cNvPr id="35" name="TextBox 34"/>
           <p:cNvSpPr txBox="1"/>
           <p:nvPr/>
         </p:nvSpPr>
@@ -21090,7 +21033,7 @@
       </p:sp>
       <p:sp>
         <p:nvSpPr>
-          <p:cNvPr id="37" name="Oval 36"/>
+          <p:cNvPr id="36" name="Oval 35"/>
           <p:cNvSpPr/>
           <p:nvPr/>
         </p:nvSpPr>
@@ -21134,7 +21077,7 @@
       </p:sp>
       <p:sp>
         <p:nvSpPr>
-          <p:cNvPr id="38" name="TextBox 37"/>
+          <p:cNvPr id="37" name="TextBox 36"/>
           <p:cNvSpPr txBox="1"/>
           <p:nvPr/>
         </p:nvSpPr>
@@ -21169,7 +21112,7 @@
       </p:sp>
       <p:sp>
         <p:nvSpPr>
-          <p:cNvPr id="39" name="TextBox 38"/>
+          <p:cNvPr id="38" name="TextBox 37"/>
           <p:cNvSpPr txBox="1"/>
           <p:nvPr/>
         </p:nvSpPr>

</xml_diff>

<commit_message>
W02 D5 decks rebuilt on main's deck builder: the afternoon cover numbers its chapters 06 to 11
Built with mermaid-cli 11.17.0, which setup.sh pins, and rendered through LibreOffice with Carlito;
the render cache now keys on the mermaid-cli version, so every diagram was drawn again.

Co-Authored-By: Claude Opus 5.5 <noreply@anthropic.com>
Claude-Session: https://claude.ai/code/session_01XxHNkzbGeVEVShHirmt22n
</commit_message>
<xml_diff>
--- a/content/W02/D5/slides/C2_W02_D05_half2_STUDENT.pptx
+++ b/content/W02/D5/slides/C2_W02_D05_half2_STUDENT.pptx
@@ -6677,7 +6677,7 @@
                 </a:solidFill>
                 <a:latin typeface="Georgia"/>
               </a:rPr>
-              <a:t>01</a:t>
+              <a:t>06</a:t>
             </a:r>
           </a:p>
         </p:txBody>
@@ -6747,7 +6747,7 @@
                 </a:solidFill>
                 <a:latin typeface="Georgia"/>
               </a:rPr>
-              <a:t>02</a:t>
+              <a:t>07</a:t>
             </a:r>
           </a:p>
         </p:txBody>
@@ -6817,7 +6817,7 @@
                 </a:solidFill>
                 <a:latin typeface="Georgia"/>
               </a:rPr>
-              <a:t>03</a:t>
+              <a:t>08</a:t>
             </a:r>
           </a:p>
         </p:txBody>
@@ -6887,7 +6887,7 @@
                 </a:solidFill>
                 <a:latin typeface="Georgia"/>
               </a:rPr>
-              <a:t>04</a:t>
+              <a:t>09</a:t>
             </a:r>
           </a:p>
         </p:txBody>
@@ -6957,7 +6957,7 @@
                 </a:solidFill>
                 <a:latin typeface="Georgia"/>
               </a:rPr>
-              <a:t>05</a:t>
+              <a:t>10</a:t>
             </a:r>
           </a:p>
         </p:txBody>
@@ -7005,6 +7005,76 @@
         </p:nvSpPr>
         <p:spPr>
           <a:xfrm>
+            <a:off x="621792" y="6254496"/>
+            <a:ext cx="365760" cy="251205"/>
+          </a:xfrm>
+          <a:prstGeom prst="rect">
+            <a:avLst/>
+          </a:prstGeom>
+          <a:noFill/>
+        </p:spPr>
+        <p:txBody>
+          <a:bodyPr wrap="square" anchor="t" lIns="0" rIns="0" tIns="0" bIns="0">
+            <a:spAutoFit/>
+          </a:bodyPr>
+          <a:lstStyle/>
+          <a:p>
+            <a:pPr algn="l"/>
+            <a:r>
+              <a:rPr sz="1300" b="0" i="0">
+                <a:solidFill>
+                  <a:srgbClr val="D9A7FF"/>
+                </a:solidFill>
+                <a:latin typeface="Georgia"/>
+              </a:rPr>
+              <a:t>11</a:t>
+            </a:r>
+          </a:p>
+        </p:txBody>
+      </p:sp>
+      <p:sp>
+        <p:nvSpPr>
+          <p:cNvPr id="22" name="TextBox 21"/>
+          <p:cNvSpPr txBox="1"/>
+          <p:nvPr/>
+        </p:nvSpPr>
+        <p:spPr>
+          <a:xfrm>
+            <a:off x="1005839" y="6291072"/>
+            <a:ext cx="1425035" cy="185166"/>
+          </a:xfrm>
+          <a:prstGeom prst="rect">
+            <a:avLst/>
+          </a:prstGeom>
+          <a:noFill/>
+        </p:spPr>
+        <p:txBody>
+          <a:bodyPr wrap="square" anchor="t" lIns="0" rIns="0" tIns="0" bIns="0">
+            <a:spAutoFit/>
+          </a:bodyPr>
+          <a:lstStyle/>
+          <a:p>
+            <a:pPr algn="l"/>
+            <a:r>
+              <a:rPr sz="900" b="0" i="0">
+                <a:solidFill>
+                  <a:srgbClr val="FFFFFF"/>
+                </a:solidFill>
+                <a:latin typeface="Calibri"/>
+              </a:rPr>
+              <a:t>What ships on Monday?</a:t>
+            </a:r>
+          </a:p>
+        </p:txBody>
+      </p:sp>
+      <p:sp>
+        <p:nvSpPr>
+          <p:cNvPr id="23" name="TextBox 22"/>
+          <p:cNvSpPr txBox="1"/>
+          <p:nvPr/>
+        </p:nvSpPr>
+        <p:spPr>
+          <a:xfrm>
             <a:off x="530352" y="6437376"/>
             <a:ext cx="9667951" cy="160401"/>
           </a:xfrm>
@@ -7034,7 +7104,7 @@
       </p:sp>
       <p:sp>
         <p:nvSpPr>
-          <p:cNvPr id="22" name="TextBox 21"/>
+          <p:cNvPr id="24" name="TextBox 23"/>
           <p:cNvSpPr txBox="1"/>
           <p:nvPr/>
         </p:nvSpPr>
@@ -9670,7 +9740,7 @@
       </p:sp>
       <p:pic>
         <p:nvPicPr>
-          <p:cNvPr id="9" name="mermaid diagram" descr="959843e9f17d6a76.png"/>
+          <p:cNvPr id="9" name="mermaid diagram" descr="93eb2a503635aabd.png"/>
           <p:cNvPicPr>
             <a:picLocks noChangeAspect="1"/>
           </p:cNvPicPr>
@@ -11593,7 +11663,7 @@
       </p:sp>
       <p:pic>
         <p:nvPicPr>
-          <p:cNvPr id="9" name="mermaid diagram" descr="081f2d1971e1367d.png"/>
+          <p:cNvPr id="9" name="mermaid diagram" descr="9069b515ed66f42d.png"/>
           <p:cNvPicPr>
             <a:picLocks noChangeAspect="1"/>
           </p:cNvPicPr>
@@ -13728,7 +13798,7 @@
       </p:sp>
       <p:pic>
         <p:nvPicPr>
-          <p:cNvPr id="9" name="mermaid diagram" descr="5bdf619cf4d5298f.png"/>
+          <p:cNvPr id="9" name="mermaid diagram" descr="3b32a90bcdcd62d4.png"/>
           <p:cNvPicPr>
             <a:picLocks noChangeAspect="1"/>
           </p:cNvPicPr>
@@ -16414,7 +16484,7 @@
                 </a:solidFill>
                 <a:latin typeface="Calibri"/>
               </a:rPr>
-              <a:t>Week 2, Day 5. Can a director change it and still trust it?</a:t>
+              <a:t>Week 2, Day 5. What can a director open, change and still trust?</a:t>
             </a:r>
           </a:p>
         </p:txBody>
@@ -18472,7 +18542,7 @@
                 </a:solidFill>
                 <a:latin typeface="Calibri"/>
               </a:rPr>
-              <a:t>Week 2, Day 5. Can a director change it and still trust it?</a:t>
+              <a:t>Week 2, Day 5. What can a director open, change and still trust?</a:t>
             </a:r>
           </a:p>
         </p:txBody>
@@ -21058,7 +21128,7 @@
                 </a:solidFill>
                 <a:latin typeface="Calibri"/>
               </a:rPr>
-              <a:t>Week 2, Day 5. Can a director change it and still trust it?</a:t>
+              <a:t>Week 2, Day 5. What can a director open, change and still trust?</a:t>
             </a:r>
           </a:p>
         </p:txBody>
@@ -22662,7 +22732,7 @@
       </p:sp>
       <p:pic>
         <p:nvPicPr>
-          <p:cNvPr id="9" name="mermaid diagram" descr="239b5ec34f9aa141.png"/>
+          <p:cNvPr id="9" name="mermaid diagram" descr="d248a8f9a2fa2501.png"/>
           <p:cNvPicPr>
             <a:picLocks noChangeAspect="1"/>
           </p:cNvPicPr>
@@ -23573,7 +23643,7 @@
       </p:sp>
       <p:pic>
         <p:nvPicPr>
-          <p:cNvPr id="9" name="mermaid diagram" descr="9207a882d369c949.png"/>
+          <p:cNvPr id="9" name="mermaid diagram" descr="bf26c508d5e45704.png"/>
           <p:cNvPicPr>
             <a:picLocks noChangeAspect="1"/>
           </p:cNvPicPr>
@@ -24779,7 +24849,7 @@
                 </a:solidFill>
                 <a:latin typeface="Calibri"/>
               </a:rPr>
-              <a:t>Week 2, Day 5. Can a director change it and still trust it?</a:t>
+              <a:t>Week 2, Day 5. What can a director open, change and still trust?</a:t>
             </a:r>
           </a:p>
         </p:txBody>
@@ -26105,7 +26175,7 @@
       </p:sp>
       <p:pic>
         <p:nvPicPr>
-          <p:cNvPr id="9" name="mermaid diagram" descr="ad41dcc4abb70657.png"/>
+          <p:cNvPr id="9" name="mermaid diagram" descr="fe8bcebd325752f9.png"/>
           <p:cNvPicPr>
             <a:picLocks noChangeAspect="1"/>
           </p:cNvPicPr>
@@ -26918,7 +26988,7 @@
       </p:sp>
       <p:pic>
         <p:nvPicPr>
-          <p:cNvPr id="9" name="mermaid diagram" descr="7a33375b7393d3e7.png"/>
+          <p:cNvPr id="9" name="mermaid diagram" descr="d54ae14364966769.png"/>
           <p:cNvPicPr>
             <a:picLocks noChangeAspect="1"/>
           </p:cNvPicPr>
@@ -32997,7 +33067,7 @@
                 </a:solidFill>
                 <a:latin typeface="Calibri"/>
               </a:rPr>
-              <a:t>Week 2, Day 5. Can a director change it and still trust it?</a:t>
+              <a:t>Week 2, Day 5. What can a director open, change and still trust?</a:t>
             </a:r>
           </a:p>
         </p:txBody>
@@ -34654,7 +34724,7 @@
       </p:sp>
       <p:pic>
         <p:nvPicPr>
-          <p:cNvPr id="9" name="mermaid diagram" descr="17b75dcda3b5714a.png"/>
+          <p:cNvPr id="9" name="mermaid diagram" descr="b2aabb1846aeb5c2.png"/>
           <p:cNvPicPr>
             <a:picLocks noChangeAspect="1"/>
           </p:cNvPicPr>
@@ -35860,7 +35930,7 @@
                 </a:solidFill>
                 <a:latin typeface="Calibri"/>
               </a:rPr>
-              <a:t>Week 2, Day 5. Can a director change it and still trust it?</a:t>
+              <a:t>Week 2, Day 5. What can a director open, change and still trust?</a:t>
             </a:r>
           </a:p>
         </p:txBody>
@@ -36239,7 +36309,7 @@
       </p:sp>
       <p:pic>
         <p:nvPicPr>
-          <p:cNvPr id="11" name="mermaid diagram" descr="d6dc06a7beb778fa.png"/>
+          <p:cNvPr id="11" name="mermaid diagram" descr="4e2992764398c9ed.png"/>
           <p:cNvPicPr>
             <a:picLocks noChangeAspect="1"/>
           </p:cNvPicPr>
@@ -38475,7 +38545,7 @@
       </p:sp>
       <p:pic>
         <p:nvPicPr>
-          <p:cNvPr id="17" name="mermaid diagram" descr="06b3dc94828f3627.png"/>
+          <p:cNvPr id="17" name="mermaid diagram" descr="eb5525876ecd60eb.png"/>
           <p:cNvPicPr>
             <a:picLocks noChangeAspect="1"/>
           </p:cNvPicPr>
@@ -44478,7 +44548,7 @@
       </p:sp>
       <p:pic>
         <p:nvPicPr>
-          <p:cNvPr id="9" name="mermaid diagram" descr="313f128d31774d0b.png"/>
+          <p:cNvPr id="9" name="mermaid diagram" descr="2dc8937eb9b4b5cb.png"/>
           <p:cNvPicPr>
             <a:picLocks noChangeAspect="1"/>
           </p:cNvPicPr>
@@ -46613,7 +46683,7 @@
       </p:sp>
       <p:pic>
         <p:nvPicPr>
-          <p:cNvPr id="9" name="mermaid diagram" descr="ce422415f54af223.png"/>
+          <p:cNvPr id="9" name="mermaid diagram" descr="bfe3f39a11262cba.png"/>
           <p:cNvPicPr>
             <a:picLocks noChangeAspect="1"/>
           </p:cNvPicPr>

</xml_diff>

<commit_message>
W02 D5 decks rebuilt from the edited sources, and the companion's lookup ids named in the provenance
Co-Authored-By: Claude Opus 5.5 <noreply@anthropic.com>
Claude-Session: https://claude.ai/code/session_01XxHNkzbGeVEVShHirmt22n
</commit_message>
<xml_diff>
--- a/content/W02/D5/slides/C2_W02_D05_half2_STUDENT.pptx
+++ b/content/W02/D5/slides/C2_W02_D05_half2_STUDENT.pptx
@@ -1224,7 +1224,7 @@
           <a:lstStyle/>
           <a:p>
             <a:r>
-              <a:t>LIVE. Fifty minutes, unguided. The support TA answers environment problems only. The brief is</a:t>
+              <a:t>LIVE, fifty minutes, unguided. The support TA answers environment problems only. The brief is</a:t>
             </a:r>
           </a:p>
           <a:p>
@@ -1374,7 +1374,7 @@
           <a:lstStyle/>
           <a:p>
             <a:r>
-              <a:t>LIVE. Thirty minutes. Notebook C2_W02_D05_06_director_proof beside it; the reference workbook,</a:t>
+              <a:t>LIVE, thirty minutes, with notebook C2_W02_D05_06_director_proof beside it; the reference workbook,</a:t>
             </a:r>
           </a:p>
           <a:p>
@@ -1519,7 +1519,7 @@
           <a:lstStyle/>
           <a:p>
             <a:r>
-              <a:t>LIVE. Fifteen minutes. Collect the room's wrong numbers during the case and show the ones that actually</a:t>
+              <a:t>LIVE, fifteen minutes. Collect the room's wrong numbers during the case and show the ones that actually</a:t>
             </a:r>
           </a:p>
           <a:p>
@@ -1814,7 +1814,7 @@
           <a:lstStyle/>
           <a:p>
             <a:r>
-              <a:t>LIVE. Forty minutes in pairs: one plays the director, one defends the rule, then they swap. The brief is</a:t>
+              <a:t>LIVE, forty minutes in pairs: one plays the director, one defends the rule, then they swap. The brief is</a:t>
             </a:r>
           </a:p>
           <a:p>
@@ -2344,7 +2344,7 @@
           <a:lstStyle/>
           <a:p>
             <a:r>
-              <a:t>LIVE. Twenty minutes in pairs: one asks, one answers in under a minute, then swap.</a:t>
+              <a:t>LIVE, twenty minutes in pairs: one asks, one answers in under a minute, then swap.</a:t>
             </a:r>
           </a:p>
         </p:txBody>
@@ -2564,7 +2564,7 @@
           <a:lstStyle/>
           <a:p>
             <a:r>
-              <a:t>LIVE. Fifteen minutes: the sentence (2), the six lines (2), the Kahoot (9), tomorrow (2).</a:t>
+              <a:t>LIVE, fifteen minutes: the sentence (2), the six lines (2), the Kahoot (9), tomorrow (2).</a:t>
             </a:r>
           </a:p>
         </p:txBody>
@@ -14618,8 +14618,8 @@
           <p:nvPr/>
         </p:nvGraphicFramePr>
         <p:xfrm>
-          <a:off x="530352" y="1794764"/>
-          <a:ext cx="11130991" cy="2226056"/>
+          <a:off x="530352" y="1819656"/>
+          <a:ext cx="11130991" cy="2176272"/>
         </p:xfrm>
         <a:graphic>
           <a:graphicData uri="http://schemas.openxmlformats.org/drawingml/2006/table">
@@ -14628,17 +14628,17 @@
                 <a:tableStyleId>{2D5ABB26-0587-4C30-8999-92F81FD0307C}</a:tableStyleId>
               </a:tblPr>
               <a:tblGrid>
-                <a:gridCol w="3038060"/>
-                <a:gridCol w="8092931"/>
+                <a:gridCol w="3081542"/>
+                <a:gridCol w="8049449"/>
               </a:tblGrid>
-              <a:tr h="318008">
+              <a:tr h="310896">
                 <a:tc>
                   <a:txBody>
                     <a:bodyPr/>
                     <a:lstStyle/>
                     <a:p>
                       <a:r>
-                        <a:rPr sz="1150" b="1" i="0">
+                        <a:rPr sz="950" b="1" i="0">
                           <a:solidFill>
                             <a:srgbClr val="FFFFFF"/>
                           </a:solidFill>
@@ -14660,7 +14660,7 @@
                     <a:lstStyle/>
                     <a:p>
                       <a:r>
-                        <a:rPr sz="1150" b="1" i="0">
+                        <a:rPr sz="950" b="1" i="0">
                           <a:solidFill>
                             <a:srgbClr val="FFFFFF"/>
                           </a:solidFill>
@@ -14677,14 +14677,14 @@
                   </a:tcPr>
                 </a:tc>
               </a:tr>
-              <a:tr h="318008">
+              <a:tr h="310896">
                 <a:tc>
                   <a:txBody>
                     <a:bodyPr/>
                     <a:lstStyle/>
                     <a:p>
                       <a:r>
-                        <a:rPr sz="1100" b="0" i="0">
+                        <a:rPr sz="900" b="0" i="0">
                           <a:solidFill>
                             <a:srgbClr val="1A1440"/>
                           </a:solidFill>
@@ -14706,7 +14706,7 @@
                     <a:lstStyle/>
                     <a:p>
                       <a:r>
-                        <a:rPr sz="1100" b="0" i="0">
+                        <a:rPr sz="900" b="0" i="0">
                           <a:solidFill>
                             <a:srgbClr val="1A1440"/>
                           </a:solidFill>
@@ -14723,14 +14723,14 @@
                   </a:tcPr>
                 </a:tc>
               </a:tr>
-              <a:tr h="318008">
+              <a:tr h="310896">
                 <a:tc>
                   <a:txBody>
                     <a:bodyPr/>
                     <a:lstStyle/>
                     <a:p>
                       <a:r>
-                        <a:rPr sz="1100" b="0" i="0">
+                        <a:rPr sz="900" b="0" i="0">
                           <a:solidFill>
                             <a:srgbClr val="1A1440"/>
                           </a:solidFill>
@@ -14752,7 +14752,7 @@
                     <a:lstStyle/>
                     <a:p>
                       <a:r>
-                        <a:rPr sz="1100" b="0" i="0">
+                        <a:rPr sz="900" b="0" i="0">
                           <a:solidFill>
                             <a:srgbClr val="1A1440"/>
                           </a:solidFill>
@@ -14769,14 +14769,14 @@
                   </a:tcPr>
                 </a:tc>
               </a:tr>
-              <a:tr h="318008">
+              <a:tr h="310896">
                 <a:tc>
                   <a:txBody>
                     <a:bodyPr/>
                     <a:lstStyle/>
                     <a:p>
                       <a:r>
-                        <a:rPr sz="1100" b="0" i="0">
+                        <a:rPr sz="900" b="0" i="0">
                           <a:solidFill>
                             <a:srgbClr val="1A1440"/>
                           </a:solidFill>
@@ -14798,7 +14798,7 @@
                     <a:lstStyle/>
                     <a:p>
                       <a:r>
-                        <a:rPr sz="1100" b="0" i="0">
+                        <a:rPr sz="900" b="0" i="0">
                           <a:solidFill>
                             <a:srgbClr val="1A1440"/>
                           </a:solidFill>
@@ -14815,14 +14815,14 @@
                   </a:tcPr>
                 </a:tc>
               </a:tr>
-              <a:tr h="318008">
+              <a:tr h="310896">
                 <a:tc>
                   <a:txBody>
                     <a:bodyPr/>
                     <a:lstStyle/>
                     <a:p>
                       <a:r>
-                        <a:rPr sz="1100" b="0" i="0">
+                        <a:rPr sz="900" b="0" i="0">
                           <a:solidFill>
                             <a:srgbClr val="1A1440"/>
                           </a:solidFill>
@@ -14844,7 +14844,7 @@
                     <a:lstStyle/>
                     <a:p>
                       <a:r>
-                        <a:rPr sz="1100" b="0" i="0">
+                        <a:rPr sz="900" b="0" i="0">
                           <a:solidFill>
                             <a:srgbClr val="1A1440"/>
                           </a:solidFill>
@@ -14861,14 +14861,14 @@
                   </a:tcPr>
                 </a:tc>
               </a:tr>
-              <a:tr h="318008">
+              <a:tr h="310896">
                 <a:tc>
                   <a:txBody>
                     <a:bodyPr/>
                     <a:lstStyle/>
                     <a:p>
                       <a:r>
-                        <a:rPr sz="1100" b="0" i="0">
+                        <a:rPr sz="900" b="0" i="0">
                           <a:solidFill>
                             <a:srgbClr val="1A1440"/>
                           </a:solidFill>
@@ -14890,7 +14890,7 @@
                     <a:lstStyle/>
                     <a:p>
                       <a:r>
-                        <a:rPr sz="1100" b="0" i="0">
+                        <a:rPr sz="900" b="0" i="0">
                           <a:solidFill>
                             <a:srgbClr val="1A1440"/>
                           </a:solidFill>
@@ -14907,14 +14907,14 @@
                   </a:tcPr>
                 </a:tc>
               </a:tr>
-              <a:tr h="318008">
+              <a:tr h="310896">
                 <a:tc>
                   <a:txBody>
                     <a:bodyPr/>
                     <a:lstStyle/>
                     <a:p>
                       <a:r>
-                        <a:rPr sz="1100" b="0" i="0">
+                        <a:rPr sz="900" b="0" i="0">
                           <a:solidFill>
                             <a:srgbClr val="1A1440"/>
                           </a:solidFill>
@@ -14936,7 +14936,7 @@
                     <a:lstStyle/>
                     <a:p>
                       <a:r>
-                        <a:rPr sz="1100" b="0" i="0">
+                        <a:rPr sz="900" b="0" i="0">
                           <a:solidFill>
                             <a:srgbClr val="1A1440"/>
                           </a:solidFill>
@@ -14965,7 +14965,7 @@
         </p:nvSpPr>
         <p:spPr>
           <a:xfrm>
-            <a:off x="530352" y="4276852"/>
+            <a:off x="530352" y="4251960"/>
             <a:ext cx="11130991" cy="822960"/>
           </a:xfrm>
           <a:prstGeom prst="roundRect">
@@ -15019,7 +15019,7 @@
         </p:nvSpPr>
         <p:spPr>
           <a:xfrm>
-            <a:off x="758952" y="4459732"/>
+            <a:off x="758952" y="4434840"/>
             <a:ext cx="457200" cy="457200"/>
           </a:xfrm>
           <a:prstGeom prst="ellipse">
@@ -15071,7 +15071,7 @@
         </p:blipFill>
         <p:spPr>
           <a:xfrm>
-            <a:off x="868680" y="4569460"/>
+            <a:off x="868680" y="4544568"/>
             <a:ext cx="237744" cy="237744"/>
           </a:xfrm>
           <a:prstGeom prst="rect">
@@ -15087,7 +15087,7 @@
         </p:nvSpPr>
         <p:spPr>
           <a:xfrm>
-            <a:off x="1399031" y="4423156"/>
+            <a:off x="1399031" y="4398264"/>
             <a:ext cx="9987991" cy="160401"/>
           </a:xfrm>
           <a:prstGeom prst="rect">
@@ -15122,7 +15122,7 @@
         </p:nvSpPr>
         <p:spPr>
           <a:xfrm>
-            <a:off x="1399031" y="4642612"/>
+            <a:off x="1399031" y="4617720"/>
             <a:ext cx="9987991" cy="384048"/>
           </a:xfrm>
           <a:prstGeom prst="rect">
@@ -15137,13 +15137,13 @@
           <a:lstStyle/>
           <a:p>
             <a:r>
-              <a:rPr sz="1100" b="0" i="0">
+              <a:rPr sz="1000" b="0" i="0">
                 <a:solidFill>
                   <a:srgbClr val="1A1440"/>
                 </a:solidFill>
                 <a:latin typeface="Calibri"/>
               </a:rPr>
-              <a:t>"A director who filters, sorts or asks a what-if should see a number move, and never a number lie."</a:t>
+              <a:t>"A director who filters, sorts or asks a what-if should see the right numbers move, and see a wrong one turn red before anyone reads it out."</a:t>
             </a:r>
           </a:p>
         </p:txBody>
@@ -15156,7 +15156,7 @@
         </p:nvSpPr>
         <p:spPr>
           <a:xfrm>
-            <a:off x="530352" y="5264404"/>
+            <a:off x="530352" y="5239512"/>
             <a:ext cx="11130991" cy="822960"/>
           </a:xfrm>
           <a:prstGeom prst="roundRect">
@@ -15210,7 +15210,7 @@
         </p:nvSpPr>
         <p:spPr>
           <a:xfrm>
-            <a:off x="758952" y="5447284"/>
+            <a:off x="758952" y="5422392"/>
             <a:ext cx="457200" cy="457200"/>
           </a:xfrm>
           <a:prstGeom prst="ellipse">
@@ -15262,7 +15262,7 @@
         </p:blipFill>
         <p:spPr>
           <a:xfrm>
-            <a:off x="868680" y="5557012"/>
+            <a:off x="868680" y="5532120"/>
             <a:ext cx="237744" cy="237744"/>
           </a:xfrm>
           <a:prstGeom prst="rect">
@@ -15278,7 +15278,7 @@
         </p:nvSpPr>
         <p:spPr>
           <a:xfrm>
-            <a:off x="1399031" y="5410708"/>
+            <a:off x="1399031" y="5385816"/>
             <a:ext cx="9987991" cy="160401"/>
           </a:xfrm>
           <a:prstGeom prst="rect">
@@ -15313,7 +15313,7 @@
         </p:nvSpPr>
         <p:spPr>
           <a:xfrm>
-            <a:off x="1399031" y="5630164"/>
+            <a:off x="1399031" y="5605272"/>
             <a:ext cx="9987991" cy="384048"/>
           </a:xfrm>
           <a:prstGeom prst="rect">
@@ -15328,7 +15328,7 @@
           <a:lstStyle/>
           <a:p>
             <a:r>
-              <a:rPr sz="1100" b="0" i="0">
+              <a:rPr sz="1000" b="0" i="0">
                 <a:solidFill>
                   <a:srgbClr val="1A1440"/>
                 </a:solidFill>

</xml_diff>

<commit_message>
W02 D5 decks: chapter 5 counts every payment once, maps open on the options, predicts on the slide before each answer, notes end on transitions
Co-Authored-By: Claude Opus 5.5 <noreply@anthropic.com>
Claude-Session: https://claude.ai/code/session_01XxHNkzbGeVEVShHirmt22n
</commit_message>
<xml_diff>
--- a/content/W02/D5/slides/C2_W02_D05_half2_STUDENT.pptx
+++ b/content/W02/D5/slides/C2_W02_D05_half2_STUDENT.pptx
@@ -552,6 +552,11 @@
               <a:t>numbers, the director's edit in pairs, the interview drill, and the close.</a:t>
             </a:r>
           </a:p>
+          <a:p>
+            <a:r>
+              <a:t>Transition: when a director takes the workbook in the room, what can they break, and which checks catch it before anyone reads a wrong number? The chief of staff's last condition rides on it.</a:t>
+            </a:r>
+          </a:p>
         </p:txBody>
       </p:sp>
       <p:sp>
@@ -627,6 +632,11 @@
               <a:t>Delhi carries Rs 2,21,150 on 16 members; Mumbai is the second-largest city on the list.</a:t>
             </a:r>
           </a:p>
+          <a:p>
+            <a:r>
+              <a:t>Transition: what do SUBTOTAL(109) and SUBTOTAL(103) say, filtered or hidden by hand?</a:t>
+            </a:r>
+          </a:p>
         </p:txBody>
       </p:sp>
       <p:sp>
@@ -702,6 +712,11 @@
               <a:t>SUBTOTAL(109) gave 40: the same rule. The label beside the foot says which rows it adds.</a:t>
             </a:r>
           </a:p>
+          <a:p>
+            <a:r>
+              <a:t>Transition: does a total that reads the city, and never the screen, agree with the foot?</a:t>
+            </a:r>
+          </a:p>
         </p:txBody>
       </p:sp>
       <p:sp>
@@ -769,12 +784,22 @@
           <a:lstStyle/>
           <a:p>
             <a:r>
-              <a:t>LIVE, 2 minutes. The second route does not depend on the filter, so it can disagree with the foot. Put</a:t>
-            </a:r>
-          </a:p>
-          <a:p>
-            <a:r>
-              <a:t>it on the Checks tab as the foot's partner.</a:t>
+              <a:t>LIVE, 2 minutes. The second route does not depend on the screen, so it can disagree with the foot,</a:t>
+            </a:r>
+          </a:p>
+          <a:p>
+            <a:r>
+              <a:t>and here it does the moment someone hides a row by hand. Before reading a foot aloud, ask what else</a:t>
+            </a:r>
+          </a:p>
+          <a:p>
+            <a:r>
+              <a:t>was hidden.</a:t>
+            </a:r>
+          </a:p>
+          <a:p>
+            <a:r>
+              <a:t>Transition: a director asks what a Rs 500 voucher for every member on the list would cost; where does the Rs 500 go?</a:t>
             </a:r>
           </a:p>
         </p:txBody>
@@ -852,6 +877,11 @@
               <a:t>reads it and the rows on screen.</a:t>
             </a:r>
           </a:p>
+          <a:p>
+            <a:r>
+              <a:t>Transition: what happens when the director changes the input?</a:t>
+            </a:r>
+          </a:p>
         </p:txBody>
       </p:sp>
       <p:sp>
@@ -927,6 +957,11 @@
               <a:t>the source is untouched.</a:t>
             </a:r>
           </a:p>
+          <a:p>
+            <a:r>
+              <a:t>Transition: five checks each compare the sheet with something outside it; what does the release hold when one fails?</a:t>
+            </a:r>
+          </a:p>
         </p:txBody>
       </p:sp>
       <p:sp>
@@ -1002,6 +1037,11 @@
               <a:t>returns TRUE or FALSE" (Microsoft Support, checked 30 September 2026). Letters first.</a:t>
             </a:r>
           </a:p>
+          <a:p>
+            <a:r>
+              <a:t>Transition: what does each failing check hold, and why is a typed-over figure different?</a:t>
+            </a:r>
+          </a:p>
         </p:txBody>
       </p:sp>
       <p:sp>
@@ -1082,6 +1122,11 @@
               <a:t>to be rerun.</a:t>
             </a:r>
           </a:p>
+          <a:p>
+            <a:r>
+              <a:t>Transition: what can a director break, and which checks catch it?</a:t>
+            </a:r>
+          </a:p>
         </p:txBody>
       </p:sp>
       <p:sp>
@@ -1157,6 +1202,11 @@
               <a:t>screen, SUBTOTAL(103) counts it; Mumbai Rs 7,14,890 against Rs 1,56,790.</a:t>
             </a:r>
           </a:p>
+          <a:p>
+            <a:r>
+              <a:t>Transition: can you build the three deliverables and the Checks tab from the two exports, alone? The chief of staff opens it on Monday.</a:t>
+            </a:r>
+          </a:p>
         </p:txBody>
       </p:sp>
       <p:sp>
@@ -1237,6 +1287,11 @@
               <a:t>notebooks/C2_W02_D05_ex1_escalated_case_STUDENT.ipynb. Solutions open at the debrief.</a:t>
             </a:r>
           </a:p>
+          <a:p>
+            <a:r>
+              <a:t>Transition: what does the chief of staff want, and how long does each part take?</a:t>
+            </a:r>
+          </a:p>
         </p:txBody>
       </p:sp>
       <p:sp>
@@ -1304,7 +1359,17 @@
           <a:lstStyle/>
           <a:p>
             <a:r>
-              <a:t>LIVE, 3 minutes. Read the brief aloud, point at the five parts and start the clock: 47 minutes of work.</a:t>
+              <a:t>LIVE, the brief takes 3 minutes of the section's opening; then start the clock for the brief's 50</a:t>
+            </a:r>
+          </a:p>
+          <a:p>
+            <a:r>
+              <a:t>minutes of work, ten for each part.</a:t>
+            </a:r>
+          </a:p>
+          <a:p>
+            <a:r>
+              <a:t>Transition: which checks must the file pass before it goes to Monday?</a:t>
             </a:r>
           </a:p>
         </p:txBody>
@@ -1382,6 +1447,11 @@
               <a:t>demos/C2_W02_D05_deck_pack_STUDENT.xlsx, open in Excel.</a:t>
             </a:r>
           </a:p>
+          <a:p>
+            <a:r>
+              <a:t>Transition: who changes the workbook in the room, and which six questions make it safe to hand over?</a:t>
+            </a:r>
+          </a:p>
         </p:txBody>
       </p:sp>
       <p:sp>
@@ -1449,7 +1519,12 @@
           <a:lstStyle/>
           <a:p>
             <a:r>
-              <a:t>SELF-STUDY, leave on screen during the case. The reference workbook in demos/ has exactly this tab.</a:t>
+              <a:t>SELF-STUDY, on screen for the case's 50 minutes. The reference workbook in demos/ has this tab.</a:t>
+            </a:r>
+          </a:p>
+          <a:p>
+            <a:r>
+              <a:t>Transition: which wrong numbers did this room produce, in the order the day produced them? Every one was plausible.</a:t>
             </a:r>
           </a:p>
         </p:txBody>
@@ -1519,12 +1594,17 @@
           <a:lstStyle/>
           <a:p>
             <a:r>
-              <a:t>LIVE, fifteen minutes. Collect the room's wrong numbers during the case and show the ones that actually</a:t>
-            </a:r>
-          </a:p>
-          <a:p>
-            <a:r>
-              <a:t>appeared; the table on S18 is the list most rooms produce.</a:t>
+              <a:t>LIVE, fifteen minutes. Collect the room's wrong numbers during the case and show the ones that</a:t>
+            </a:r>
+          </a:p>
+          <a:p>
+            <a:r>
+              <a:t>appeared; the table on the next slide is the list most rooms produce.</a:t>
+            </a:r>
+          </a:p>
+          <a:p>
+            <a:r>
+              <a:t>Transition: which wrong numbers appeared, and what would each have done?</a:t>
             </a:r>
           </a:p>
         </p:txBody>
@@ -1602,6 +1682,11 @@
               <a:t>shaming: each is the number a hurried sheet shows.</a:t>
             </a:r>
           </a:p>
+          <a:p>
+            <a:r>
+              <a:t>Transition: if the list's export does not tie while the tree and the card do, what does the Checks tab hold?</a:t>
+            </a:r>
+          </a:p>
         </p:txBody>
       </p:sp>
       <p:sp>
@@ -1672,6 +1757,11 @@
               <a:t>LIVE, 2 minutes. Letters. Those who did chapter 3's your-turn step should know.</a:t>
             </a:r>
           </a:p>
+          <a:p>
+            <a:r>
+              <a:t>Transition: what goes to the data platform lead, and what does the chief of staff hear?</a:t>
+            </a:r>
+          </a:p>
         </p:txBody>
       </p:sp>
       <p:sp>
@@ -1747,6 +1837,11 @@
               <a:t>since the room has found it. BREAK, 10 minutes, after this slide.</a:t>
             </a:r>
           </a:p>
+          <a:p>
+            <a:r>
+              <a:t>Transition: a director wants five lakh typed into the source; can the sheet show that number and still be the one Finance signs? Pairs defend the rule, then swap.</a:t>
+            </a:r>
+          </a:p>
         </p:txBody>
       </p:sp>
       <p:sp>
@@ -1814,17 +1909,27 @@
           <a:lstStyle/>
           <a:p>
             <a:r>
-              <a:t>LIVE, forty minutes in pairs: one plays the director, one defends the rule, then they swap. The brief is</a:t>
-            </a:r>
-          </a:p>
-          <a:p>
-            <a:r>
-              <a:t>exercises/unguided/C2_W02_D05_director_edit_STUDENT.md; the notebook is</a:t>
+              <a:t>LIVE, forty minutes in pairs: the notebook 15, the role play 15 with one round each way, the three</a:t>
+            </a:r>
+          </a:p>
+          <a:p>
+            <a:r>
+              <a:t>lines 10. One partner plays the director, one defends the rule, then they swap. The brief is</a:t>
+            </a:r>
+          </a:p>
+          <a:p>
+            <a:r>
+              <a:t>exercises/unguided/C2_W02_D05_director_STUDENT.md; the notebook is</a:t>
             </a:r>
           </a:p>
           <a:p>
             <a:r>
               <a:t>notebooks/C2_W02_D05_ex2_second_case_STUDENT.ipynb.</a:t>
+            </a:r>
+          </a:p>
+          <a:p>
+            <a:r>
+              <a:t>Transition: what does the director ask, with the sheet on the projector?</a:t>
             </a:r>
           </a:p>
         </p:txBody>
@@ -1899,7 +2004,12 @@
           </a:p>
           <a:p>
             <a:r>
-              <a:t>a file. The pair's job: yes to the question, no to the edit.</a:t>
+              <a:t>a file. The pair's job is to answer the question and refuse the edit.</a:t>
+            </a:r>
+          </a:p>
+          <a:p>
+            <a:r>
+              <a:t>Transition: what does the card show after the edit, and what happens on Monday's refresh?</a:t>
             </a:r>
           </a:p>
         </p:txBody>
@@ -1969,12 +2079,22 @@
           <a:lstStyle/>
           <a:p>
             <a:r>
-              <a:t>LIVE, 4 minutes. Notebook ex2, steps 1 to 4. The drift check that catches it is the sheet's Q2 total</a:t>
-            </a:r>
-          </a:p>
-          <a:p>
-            <a:r>
-              <a:t>against the warehouse's; the typed-over check is ISFORMULA on the cell.</a:t>
+              <a:t>LIVE, 4 minutes, inside the notebook's 15. Notebook ex2, steps 1 to 4. The drift check that catches it</a:t>
+            </a:r>
+          </a:p>
+          <a:p>
+            <a:r>
+              <a:t>is the sheet's Q2 total against the warehouse's control total, live on the Checks tab; the typed-over</a:t>
+            </a:r>
+          </a:p>
+          <a:p>
+            <a:r>
+              <a:t>check is ISFORMULA on the cell.</a:t>
+            </a:r>
+          </a:p>
+          <a:p>
+            <a:r>
+              <a:t>Transition: where does the director's five lakh go, so the card shows it and the source stays Finance's?</a:t>
             </a:r>
           </a:p>
         </p:txBody>
@@ -2047,6 +2167,11 @@
               <a:t>LIVE, 2 minutes. Letters, then each pair says why their letter survives the director's pushback.</a:t>
             </a:r>
           </a:p>
+          <a:p>
+            <a:r>
+              <a:t>Transition: what does the card show, and what does each line come from?</a:t>
+            </a:r>
+          </a:p>
         </p:txBody>
       </p:sp>
       <p:sp>
@@ -2114,12 +2239,17 @@
           <a:lstStyle/>
           <a:p>
             <a:r>
-              <a:t>LIVE, 4 minutes. Then the role play: 10 minutes each way, walking the room. Listen for anyone who says</a:t>
-            </a:r>
-          </a:p>
-          <a:p>
-            <a:r>
-              <a:t>no to the question as well as to the edit.</a:t>
+              <a:t>LIVE, 4 minutes, closing the notebook's 15. Then the role play: 15 minutes, one round each way,</a:t>
+            </a:r>
+          </a:p>
+          <a:p>
+            <a:r>
+              <a:t>walking the room. Listen for anyone who refuses the question as well as the edit.</a:t>
+            </a:r>
+          </a:p>
+          <a:p>
+            <a:r>
+              <a:t>Transition: what does one partner say to the director?</a:t>
             </a:r>
           </a:p>
         </p:txBody>
@@ -2202,6 +2332,11 @@
               <a:t>the card carries its period, comparison and base, and the warehouse owns every join.</a:t>
             </a:r>
           </a:p>
+          <a:p>
+            <a:r>
+              <a:t>Transition: what does a silent change in the room cost the head of Retail-Plus?</a:t>
+            </a:r>
+          </a:p>
         </p:txBody>
       </p:sp>
       <p:sp>
@@ -2269,12 +2404,12 @@
           <a:lstStyle/>
           <a:p>
             <a:r>
-              <a:t>LIVE, 27 minutes across the role play and the notebook: 20 for the two rounds, 7 for the notebook's</a:t>
-            </a:r>
-          </a:p>
-          <a:p>
-            <a:r>
-              <a:t>five letters. Close with one pair's three lines aloud.</a:t>
+              <a:t>LIVE, the three lines' 10 minutes: each pair writes its three lines, then one pair says them aloud.</a:t>
+            </a:r>
+          </a:p>
+          <a:p>
+            <a:r>
+              <a:t>Transition: can you answer twelve screen questions aloud, each in under a minute?</a:t>
             </a:r>
           </a:p>
         </p:txBody>
@@ -2347,6 +2482,11 @@
               <a:t>LIVE, twenty minutes in pairs: one asks, one answers in under a minute, then swap.</a:t>
             </a:r>
           </a:p>
+          <a:p>
+            <a:r>
+              <a:t>Transition: which questions does a screen ask, and with which tags?</a:t>
+            </a:r>
+          </a:p>
         </p:txBody>
       </p:sp>
       <p:sp>
@@ -2427,6 +2567,11 @@
               <a:t>hundredfold.</a:t>
             </a:r>
           </a:p>
+          <a:p>
+            <a:r>
+              <a:t>Transition: what goes into a one-minute answer?</a:t>
+            </a:r>
+          </a:p>
         </p:txBody>
       </p:sp>
       <p:sp>
@@ -2497,6 +2642,11 @@
               <a:t>LIVE, 4 minutes. Read the example aloud and ask one pair to redo their weakest answer in this shape.</a:t>
             </a:r>
           </a:p>
+          <a:p>
+            <a:r>
+              <a:t>Transition: what can the chief of staff trust on Monday? The sentence, the day's six lines, the Kahoot and tomorrow.</a:t>
+            </a:r>
+          </a:p>
         </p:txBody>
       </p:sp>
       <p:sp>
@@ -2567,6 +2717,11 @@
               <a:t>LIVE, fifteen minutes: the sentence (2), the six lines (2), the Kahoot (9), tomorrow (2).</a:t>
             </a:r>
           </a:p>
+          <a:p>
+            <a:r>
+              <a:t>Transition: what does the team send the chief of staff?</a:t>
+            </a:r>
+          </a:p>
         </p:txBody>
       </p:sp>
       <p:sp>
@@ -2647,6 +2802,11 @@
               <a:t>this room's workbook should give.</a:t>
             </a:r>
           </a:p>
+          <a:p>
+            <a:r>
+              <a:t>Transition: which six lines do the cheat sheet and the notes repeat word for word?</a:t>
+            </a:r>
+          </a:p>
         </p:txBody>
       </p:sp>
       <p:sp>
@@ -2717,6 +2877,11 @@
               <a:t>LIVE, 2 minutes. Read them once. They are on the cheat sheet's panels in this order.</a:t>
             </a:r>
           </a:p>
+          <a:p>
+            <a:r>
+              <a:t>Transition: what does the room still get wrong, fast?</a:t>
+            </a:r>
+          </a:p>
         </p:txBody>
       </p:sp>
       <p:sp>
@@ -2792,6 +2957,11 @@
               <a:t>up.</a:t>
             </a:r>
           </a:p>
+          <a:p>
+            <a:r>
+              <a:t>Transition: what comes next, and which question is left open?</a:t>
+            </a:r>
+          </a:p>
         </p:txBody>
       </p:sp>
       <p:sp>
@@ -2872,6 +3042,11 @@
               <a:t>question open. The pre-read for Monday ships tonight.</a:t>
             </a:r>
           </a:p>
+          <a:p>
+            <a:r>
+              <a:t>Transition: the end of the day; the pre-read for Monday ships tonight.</a:t>
+            </a:r>
+          </a:p>
         </p:txBody>
       </p:sp>
       <p:sp>
@@ -2947,6 +3122,11 @@
               <a:t>Excel turns red when a filter changes what a number at the foot of a list means.</a:t>
             </a:r>
           </a:p>
+          <a:p>
+            <a:r>
+              <a:t>Transition: which real company paid for rows nobody could see?</a:t>
+            </a:r>
+          </a:p>
         </p:txBody>
       </p:sp>
       <p:sp>
@@ -3027,6 +3207,11 @@
               <a:t>counted.</a:t>
             </a:r>
           </a:p>
+          <a:p>
+            <a:r>
+              <a:t>Transition: how could the team protect the workbook, and what does each way cost?</a:t>
+            </a:r>
+          </a:p>
         </p:txBody>
       </p:sp>
       <p:sp>
@@ -3102,6 +3287,11 @@
               <a:t>export. Protection and the PDF fail the brief, since nothing recalculates.</a:t>
             </a:r>
           </a:p>
+          <a:p>
+            <a:r>
+              <a:t>Transition: of the five things a director does, which change what a number means with nothing shown?</a:t>
+            </a:r>
+          </a:p>
         </p:txBody>
       </p:sp>
       <p:sp>
@@ -3172,6 +3362,11 @@
               <a:t>LIVE, 1 minute. Letters first.</a:t>
             </a:r>
           </a:p>
+          <a:p>
+            <a:r>
+              <a:t>Transition: what does each of the five do to the sheet?</a:t>
+            </a:r>
+          </a:p>
         </p:txBody>
       </p:sp>
       <p:sp>
@@ -3239,12 +3434,17 @@
           <a:lstStyle/>
           <a:p>
             <a:r>
-              <a:t>LIVE, 2 minutes. The next two steps take the filter; step 5 takes the input; the second case after the</a:t>
-            </a:r>
-          </a:p>
-          <a:p>
-            <a:r>
-              <a:t>break takes the typed-over cell.</a:t>
+              <a:t>LIVE, 2 minutes. The next two steps take the filter, the step after them takes the input, and the</a:t>
+            </a:r>
+          </a:p>
+          <a:p>
+            <a:r>
+              <a:t>second case after the break takes the typed-over cell.</a:t>
+            </a:r>
+          </a:p>
+          <a:p>
+            <a:r>
+              <a:t>Transition: when a director filters the list to Mumbai, what does a foot of =SUM(E2:E51) read?</a:t>
             </a:r>
           </a:p>
         </p:txBody>
@@ -3320,6 +3520,11 @@
           <a:p>
             <a:r>
               <a:t>(the tab ships with SUBTOTAL). Letters before you read the foot aloud.</a:t>
+            </a:r>
+          </a:p>
+          <a:p>
+            <a:r>
+              <a:t>Transition: what is the plausible wrong answer, and what budget would it size?</a:t>
             </a:r>
           </a:p>
         </p:txBody>
@@ -6586,7 +6791,7 @@
         <p:spPr>
           <a:xfrm>
             <a:off x="621792" y="4263136"/>
-            <a:ext cx="10033711" cy="977645"/>
+            <a:ext cx="10033711" cy="663956"/>
           </a:xfrm>
           <a:prstGeom prst="rect">
             <a:avLst/>
@@ -6607,7 +6812,7 @@
                 </a:solidFill>
                 <a:latin typeface="Georgia"/>
               </a:rPr>
-              <a:t>“Everything you built this week has to survive a room that only has Excel. Which parts belong in Excel, which parts must never be in Excel, and how do you keep the two from drifting apart?”</a:t>
+              <a:t>“Which parts belong in Excel, which parts must never be in Excel, and how do you keep the two from drifting apart?”</a:t>
             </a:r>
           </a:p>
         </p:txBody>
@@ -6620,7 +6825,7 @@
         </p:nvSpPr>
         <p:spPr>
           <a:xfrm>
-            <a:off x="621792" y="5295646"/>
+            <a:off x="621792" y="4981956"/>
             <a:ext cx="10033711" cy="218186"/>
           </a:xfrm>
           <a:prstGeom prst="rect">
@@ -6655,7 +6860,7 @@
         </p:nvSpPr>
         <p:spPr>
           <a:xfrm>
-            <a:off x="621792" y="5833872"/>
+            <a:off x="621792" y="5520182"/>
             <a:ext cx="365760" cy="251205"/>
           </a:xfrm>
           <a:prstGeom prst="rect">
@@ -6690,7 +6895,7 @@
         </p:nvSpPr>
         <p:spPr>
           <a:xfrm>
-            <a:off x="1005839" y="5870448"/>
+            <a:off x="1005839" y="5556758"/>
             <a:ext cx="1602486" cy="185166"/>
           </a:xfrm>
           <a:prstGeom prst="rect">
@@ -6725,7 +6930,7 @@
         </p:nvSpPr>
         <p:spPr>
           <a:xfrm>
-            <a:off x="2791206" y="5833872"/>
+            <a:off x="2791206" y="5520182"/>
             <a:ext cx="365760" cy="251205"/>
           </a:xfrm>
           <a:prstGeom prst="rect">
@@ -6760,7 +6965,7 @@
         </p:nvSpPr>
         <p:spPr>
           <a:xfrm>
-            <a:off x="3175254" y="5870448"/>
+            <a:off x="3175254" y="5556758"/>
             <a:ext cx="1484185" cy="185166"/>
           </a:xfrm>
           <a:prstGeom prst="rect">
@@ -6795,7 +7000,7 @@
         </p:nvSpPr>
         <p:spPr>
           <a:xfrm>
-            <a:off x="4842319" y="5833872"/>
+            <a:off x="4842319" y="5520182"/>
             <a:ext cx="365760" cy="251205"/>
           </a:xfrm>
           <a:prstGeom prst="rect">
@@ -6830,7 +7035,7 @@
         </p:nvSpPr>
         <p:spPr>
           <a:xfrm>
-            <a:off x="5226367" y="5870448"/>
+            <a:off x="5226367" y="5556758"/>
             <a:ext cx="1661636" cy="185166"/>
           </a:xfrm>
           <a:prstGeom prst="rect">
@@ -6865,7 +7070,7 @@
         </p:nvSpPr>
         <p:spPr>
           <a:xfrm>
-            <a:off x="7070883" y="5833872"/>
+            <a:off x="7070883" y="5520182"/>
             <a:ext cx="365760" cy="251205"/>
           </a:xfrm>
           <a:prstGeom prst="rect">
@@ -6900,7 +7105,7 @@
         </p:nvSpPr>
         <p:spPr>
           <a:xfrm>
-            <a:off x="7454931" y="5870448"/>
+            <a:off x="7454931" y="5556758"/>
             <a:ext cx="1602486" cy="185166"/>
           </a:xfrm>
           <a:prstGeom prst="rect">
@@ -6935,7 +7140,7 @@
         </p:nvSpPr>
         <p:spPr>
           <a:xfrm>
-            <a:off x="9240297" y="5833872"/>
+            <a:off x="9240297" y="5520182"/>
             <a:ext cx="365760" cy="251205"/>
           </a:xfrm>
           <a:prstGeom prst="rect">
@@ -6970,7 +7175,7 @@
         </p:nvSpPr>
         <p:spPr>
           <a:xfrm>
-            <a:off x="9624345" y="5870448"/>
+            <a:off x="9624345" y="5556758"/>
             <a:ext cx="1425035" cy="185166"/>
           </a:xfrm>
           <a:prstGeom prst="rect">
@@ -7005,7 +7210,7 @@
         </p:nvSpPr>
         <p:spPr>
           <a:xfrm>
-            <a:off x="621792" y="6254496"/>
+            <a:off x="621792" y="5940806"/>
             <a:ext cx="365760" cy="251205"/>
           </a:xfrm>
           <a:prstGeom prst="rect">
@@ -7040,7 +7245,7 @@
         </p:nvSpPr>
         <p:spPr>
           <a:xfrm>
-            <a:off x="1005839" y="6291072"/>
+            <a:off x="1005839" y="5977382"/>
             <a:ext cx="1425035" cy="185166"/>
           </a:xfrm>
           <a:prstGeom prst="rect">
@@ -7868,7 +8073,7 @@
                 </a:solidFill>
                 <a:latin typeface="Calibri"/>
               </a:rPr>
-              <a:t>What breaks:</a:t>
+              <a:t>Why it is wrong.</a:t>
             </a:r>
             <a:r>
               <a:rPr sz="1600" b="0" i="0">
@@ -7877,7 +8082,7 @@
                 </a:solidFill>
                 <a:latin typeface="Calibri"/>
               </a:rPr>
-              <a:t> the Mumbai store head is told the members on their list spent Rs 7.15 lakh, and a retention budget sized on it is 4.6 times too big. SUM adds every row in its range, hidden or not. </a:t>
+              <a:t> SUM adds every row in its range, hidden or not, so the head of Retail-Plus is told the Mumbai members on the list spent Rs 7.15 lakh, and a Mumbai budget sized on it is 4.6 times too big. </a:t>
             </a:r>
             <a:r>
               <a:rPr sz="1600" b="1" i="0">
@@ -7886,7 +8091,7 @@
                 </a:solidFill>
                 <a:latin typeface="Calibri"/>
               </a:rPr>
-              <a:t>The check:</a:t>
+              <a:t>The check that catches it.</a:t>
             </a:r>
             <a:r>
               <a:rPr sz="1600" b="0" i="0">
@@ -7895,24 +8100,74 @@
                 </a:solidFill>
                 <a:latin typeface="Calibri"/>
               </a:rPr>
-              <a:t> count the rows on screen beside the rows the total adds.</a:t>
-            </a:r>
-          </a:p>
-        </p:txBody>
-      </p:sp>
-      <p:sp>
-        <p:nvSpPr>
-          <p:cNvPr id="22" name="Oval 21"/>
+              <a:t> Count the rows on screen beside the rows the total adds.</a:t>
+            </a:r>
+          </a:p>
+        </p:txBody>
+      </p:sp>
+      <p:sp>
+        <p:nvSpPr>
+          <p:cNvPr id="22" name="Rounded Rectangle 21"/>
           <p:cNvSpPr/>
           <p:nvPr/>
         </p:nvSpPr>
         <p:spPr>
           <a:xfrm>
-            <a:off x="530352" y="6492240"/>
-            <a:ext cx="64008" cy="64008"/>
-          </a:xfrm>
-          <a:prstGeom prst="ellipse">
-            <a:avLst/>
+            <a:off x="530352" y="4596384"/>
+            <a:ext cx="11130991" cy="807720"/>
+          </a:xfrm>
+          <a:prstGeom prst="roundRect">
+            <a:avLst>
+              <a:gd name="adj" fmla="val 8000"/>
+            </a:avLst>
+          </a:prstGeom>
+          <a:solidFill>
+            <a:srgbClr val="F7F5FD"/>
+          </a:solidFill>
+          <a:ln w="9525">
+            <a:solidFill>
+              <a:srgbClr val="E4E1F1"/>
+            </a:solidFill>
+          </a:ln>
+          <a:effectLst/>
+        </p:spPr>
+        <p:style>
+          <a:lnRef idx="1">
+            <a:schemeClr val="accent1"/>
+          </a:lnRef>
+          <a:fillRef idx="3">
+            <a:schemeClr val="accent1"/>
+          </a:fillRef>
+          <a:effectRef idx="2">
+            <a:schemeClr val="accent1"/>
+          </a:effectRef>
+          <a:fontRef idx="minor">
+            <a:schemeClr val="lt1"/>
+          </a:fontRef>
+        </p:style>
+        <p:txBody>
+          <a:bodyPr rtlCol="0" anchor="ctr" wrap="square"/>
+          <a:lstStyle/>
+          <a:p>
+            <a:pPr algn="ctr"/>
+          </a:p>
+        </p:txBody>
+      </p:sp>
+      <p:sp>
+        <p:nvSpPr>
+          <p:cNvPr id="23" name="Rounded Rectangle 22"/>
+          <p:cNvSpPr/>
+          <p:nvPr/>
+        </p:nvSpPr>
+        <p:spPr>
+          <a:xfrm>
+            <a:off x="676656" y="4724400"/>
+            <a:ext cx="45720" cy="551688"/>
+          </a:xfrm>
+          <a:prstGeom prst="roundRect">
+            <a:avLst>
+              <a:gd name="adj" fmla="val 50000"/>
+            </a:avLst>
           </a:prstGeom>
           <a:solidFill>
             <a:srgbClr val="5B3FD6"/>
@@ -7946,7 +8201,94 @@
       </p:sp>
       <p:sp>
         <p:nvSpPr>
-          <p:cNvPr id="23" name="TextBox 22"/>
+          <p:cNvPr id="24" name="TextBox 23"/>
+          <p:cNvSpPr txBox="1"/>
+          <p:nvPr/>
+        </p:nvSpPr>
+        <p:spPr>
+          <a:xfrm>
+            <a:off x="877824" y="4715256"/>
+            <a:ext cx="10564063" cy="624840"/>
+          </a:xfrm>
+          <a:prstGeom prst="rect">
+            <a:avLst/>
+          </a:prstGeom>
+          <a:noFill/>
+        </p:spPr>
+        <p:txBody>
+          <a:bodyPr wrap="square" anchor="ctr" lIns="0" rIns="0" tIns="0" bIns="0">
+            <a:spAutoFit/>
+          </a:bodyPr>
+          <a:lstStyle/>
+          <a:p>
+            <a:r>
+              <a:rPr sz="1500" b="1">
+                <a:solidFill>
+                  <a:srgbClr val="5B3FD6"/>
+                </a:solidFill>
+                <a:latin typeface="Calibri"/>
+              </a:rPr>
+              <a:t>Predict before you run. </a:t>
+            </a:r>
+            <a:r>
+              <a:rPr sz="1500" b="0" i="0">
+                <a:solidFill>
+                  <a:srgbClr val="1A1440"/>
+                </a:solidFill>
+                <a:latin typeface="Calibri"/>
+              </a:rPr>
+              <a:t>A director hides Delhi's rows by hand, with no filter on. Which foot still adds Delhi? a) SUM only; b) SUM and SUBTOTAL(9); c) SUBTOTAL(109) only; d) none of them.</a:t>
+            </a:r>
+          </a:p>
+        </p:txBody>
+      </p:sp>
+      <p:sp>
+        <p:nvSpPr>
+          <p:cNvPr id="25" name="Oval 24"/>
+          <p:cNvSpPr/>
+          <p:nvPr/>
+        </p:nvSpPr>
+        <p:spPr>
+          <a:xfrm>
+            <a:off x="530352" y="6492240"/>
+            <a:ext cx="64008" cy="64008"/>
+          </a:xfrm>
+          <a:prstGeom prst="ellipse">
+            <a:avLst/>
+          </a:prstGeom>
+          <a:solidFill>
+            <a:srgbClr val="5B3FD6"/>
+          </a:solidFill>
+          <a:ln>
+            <a:noFill/>
+          </a:ln>
+          <a:effectLst/>
+        </p:spPr>
+        <p:style>
+          <a:lnRef idx="1">
+            <a:schemeClr val="accent1"/>
+          </a:lnRef>
+          <a:fillRef idx="3">
+            <a:schemeClr val="accent1"/>
+          </a:fillRef>
+          <a:effectRef idx="2">
+            <a:schemeClr val="accent1"/>
+          </a:effectRef>
+          <a:fontRef idx="minor">
+            <a:schemeClr val="lt1"/>
+          </a:fontRef>
+        </p:style>
+        <p:txBody>
+          <a:bodyPr rtlCol="0" anchor="ctr" wrap="square"/>
+          <a:lstStyle/>
+          <a:p>
+            <a:pPr algn="ctr"/>
+          </a:p>
+        </p:txBody>
+      </p:sp>
+      <p:sp>
+        <p:nvSpPr>
+          <p:cNvPr id="26" name="TextBox 25"/>
           <p:cNvSpPr txBox="1"/>
           <p:nvPr/>
         </p:nvSpPr>
@@ -7981,7 +8323,7 @@
       </p:sp>
       <p:sp>
         <p:nvSpPr>
-          <p:cNvPr id="24" name="Oval 23"/>
+          <p:cNvPr id="27" name="Oval 26"/>
           <p:cNvSpPr/>
           <p:nvPr/>
         </p:nvSpPr>
@@ -8025,7 +8367,7 @@
       </p:sp>
       <p:sp>
         <p:nvSpPr>
-          <p:cNvPr id="25" name="TextBox 24"/>
+          <p:cNvPr id="28" name="TextBox 27"/>
           <p:cNvSpPr txBox="1"/>
           <p:nvPr/>
         </p:nvSpPr>
@@ -8060,7 +8402,7 @@
       </p:sp>
       <p:sp>
         <p:nvSpPr>
-          <p:cNvPr id="26" name="Oval 25"/>
+          <p:cNvPr id="29" name="Oval 28"/>
           <p:cNvSpPr/>
           <p:nvPr/>
         </p:nvSpPr>
@@ -8104,7 +8446,7 @@
       </p:sp>
       <p:sp>
         <p:nvSpPr>
-          <p:cNvPr id="27" name="TextBox 26"/>
+          <p:cNvPr id="30" name="TextBox 29"/>
           <p:cNvSpPr txBox="1"/>
           <p:nvPr/>
         </p:nvSpPr>
@@ -8139,7 +8481,7 @@
       </p:sp>
       <p:sp>
         <p:nvSpPr>
-          <p:cNvPr id="28" name="Oval 27"/>
+          <p:cNvPr id="31" name="Oval 30"/>
           <p:cNvSpPr/>
           <p:nvPr/>
         </p:nvSpPr>
@@ -8183,7 +8525,7 @@
       </p:sp>
       <p:sp>
         <p:nvSpPr>
-          <p:cNvPr id="29" name="TextBox 28"/>
+          <p:cNvPr id="32" name="TextBox 31"/>
           <p:cNvSpPr txBox="1"/>
           <p:nvPr/>
         </p:nvSpPr>
@@ -8218,7 +8560,7 @@
       </p:sp>
       <p:sp>
         <p:nvSpPr>
-          <p:cNvPr id="30" name="Oval 29"/>
+          <p:cNvPr id="33" name="Oval 32"/>
           <p:cNvSpPr/>
           <p:nvPr/>
         </p:nvSpPr>
@@ -8262,7 +8604,7 @@
       </p:sp>
       <p:sp>
         <p:nvSpPr>
-          <p:cNvPr id="31" name="TextBox 30"/>
+          <p:cNvPr id="34" name="TextBox 33"/>
           <p:cNvSpPr txBox="1"/>
           <p:nvPr/>
         </p:nvSpPr>
@@ -8297,7 +8639,7 @@
       </p:sp>
       <p:sp>
         <p:nvSpPr>
-          <p:cNvPr id="32" name="Oval 31"/>
+          <p:cNvPr id="35" name="Oval 34"/>
           <p:cNvSpPr/>
           <p:nvPr/>
         </p:nvSpPr>
@@ -8341,7 +8683,7 @@
       </p:sp>
       <p:sp>
         <p:nvSpPr>
-          <p:cNvPr id="33" name="TextBox 32"/>
+          <p:cNvPr id="36" name="TextBox 35"/>
           <p:cNvSpPr txBox="1"/>
           <p:nvPr/>
         </p:nvSpPr>
@@ -8376,7 +8718,7 @@
       </p:sp>
       <p:sp>
         <p:nvSpPr>
-          <p:cNvPr id="34" name="TextBox 33"/>
+          <p:cNvPr id="37" name="TextBox 36"/>
           <p:cNvSpPr txBox="1"/>
           <p:nvPr/>
         </p:nvSpPr>
@@ -8659,7 +9001,7 @@
           <p:nvPr/>
         </p:nvGraphicFramePr>
         <p:xfrm>
-          <a:off x="530352" y="1956816"/>
+          <a:off x="530352" y="1947926"/>
           <a:ext cx="11130989" cy="1479296"/>
         </p:xfrm>
         <a:graphic>
@@ -8957,7 +9299,7 @@
         </p:nvSpPr>
         <p:spPr>
           <a:xfrm>
-            <a:off x="530352" y="3692144"/>
+            <a:off x="530352" y="3683254"/>
             <a:ext cx="11130991" cy="1048512"/>
           </a:xfrm>
           <a:prstGeom prst="rect">
@@ -8983,24 +9325,74 @@
                 </a:solidFill>
                 <a:latin typeface="Calibri"/>
               </a:rPr>
-              <a:t>SUBTOTAL "ignores any rows that are not included in the result of a filter, no matter which function_num value you use", and 101 to 111 also ignore rows hidden by hand (Microsoft Support, SUBTOTAL, checked 30 September 2026). =SUBTOTAL(103, A2:A51) beside it counts 11 of 50.</a:t>
-            </a:r>
-          </a:p>
-        </p:txBody>
-      </p:sp>
-      <p:sp>
-        <p:nvSpPr>
-          <p:cNvPr id="11" name="Oval 10"/>
+              <a:t>The answer is b. SUBTOTAL "ignores any rows that are not included in the result of a filter, no matter which function_num value you use", and 101 to 111 also ignore rows hidden by hand (Microsoft Support, SUBTOTAL, checked 30 September 2026). =SUBTOTAL(103, A2:A51) beside it counts 11 of 50.</a:t>
+            </a:r>
+          </a:p>
+        </p:txBody>
+      </p:sp>
+      <p:sp>
+        <p:nvSpPr>
+          <p:cNvPr id="11" name="Rounded Rectangle 10"/>
           <p:cNvSpPr/>
           <p:nvPr/>
         </p:nvSpPr>
         <p:spPr>
           <a:xfrm>
-            <a:off x="530352" y="6492240"/>
-            <a:ext cx="64008" cy="64008"/>
-          </a:xfrm>
-          <a:prstGeom prst="ellipse">
-            <a:avLst/>
+            <a:off x="530352" y="4859781"/>
+            <a:ext cx="11130991" cy="1074420"/>
+          </a:xfrm>
+          <a:prstGeom prst="roundRect">
+            <a:avLst>
+              <a:gd name="adj" fmla="val 8000"/>
+            </a:avLst>
+          </a:prstGeom>
+          <a:solidFill>
+            <a:srgbClr val="F7F5FD"/>
+          </a:solidFill>
+          <a:ln w="9525">
+            <a:solidFill>
+              <a:srgbClr val="E4E1F1"/>
+            </a:solidFill>
+          </a:ln>
+          <a:effectLst/>
+        </p:spPr>
+        <p:style>
+          <a:lnRef idx="1">
+            <a:schemeClr val="accent1"/>
+          </a:lnRef>
+          <a:fillRef idx="3">
+            <a:schemeClr val="accent1"/>
+          </a:fillRef>
+          <a:effectRef idx="2">
+            <a:schemeClr val="accent1"/>
+          </a:effectRef>
+          <a:fontRef idx="minor">
+            <a:schemeClr val="lt1"/>
+          </a:fontRef>
+        </p:style>
+        <p:txBody>
+          <a:bodyPr rtlCol="0" anchor="ctr" wrap="square"/>
+          <a:lstStyle/>
+          <a:p>
+            <a:pPr algn="ctr"/>
+          </a:p>
+        </p:txBody>
+      </p:sp>
+      <p:sp>
+        <p:nvSpPr>
+          <p:cNvPr id="12" name="Rounded Rectangle 11"/>
+          <p:cNvSpPr/>
+          <p:nvPr/>
+        </p:nvSpPr>
+        <p:spPr>
+          <a:xfrm>
+            <a:off x="676656" y="4987797"/>
+            <a:ext cx="45720" cy="818388"/>
+          </a:xfrm>
+          <a:prstGeom prst="roundRect">
+            <a:avLst>
+              <a:gd name="adj" fmla="val 50000"/>
+            </a:avLst>
           </a:prstGeom>
           <a:solidFill>
             <a:srgbClr val="5B3FD6"/>
@@ -9034,7 +9426,94 @@
       </p:sp>
       <p:sp>
         <p:nvSpPr>
-          <p:cNvPr id="12" name="TextBox 11"/>
+          <p:cNvPr id="13" name="TextBox 12"/>
+          <p:cNvSpPr txBox="1"/>
+          <p:nvPr/>
+        </p:nvSpPr>
+        <p:spPr>
+          <a:xfrm>
+            <a:off x="877824" y="4978653"/>
+            <a:ext cx="10564063" cy="891540"/>
+          </a:xfrm>
+          <a:prstGeom prst="rect">
+            <a:avLst/>
+          </a:prstGeom>
+          <a:noFill/>
+        </p:spPr>
+        <p:txBody>
+          <a:bodyPr wrap="square" anchor="ctr" lIns="0" rIns="0" tIns="0" bIns="0">
+            <a:spAutoFit/>
+          </a:bodyPr>
+          <a:lstStyle/>
+          <a:p>
+            <a:r>
+              <a:rPr sz="1500" b="1">
+                <a:solidFill>
+                  <a:srgbClr val="5B3FD6"/>
+                </a:solidFill>
+                <a:latin typeface="Calibri"/>
+              </a:rPr>
+              <a:t>Predict before you run. </a:t>
+            </a:r>
+            <a:r>
+              <a:rPr sz="1500" b="0" i="0">
+                <a:solidFill>
+                  <a:srgbClr val="1A1440"/>
+                </a:solidFill>
+                <a:latin typeface="Calibri"/>
+              </a:rPr>
+              <a:t>With the Mumbai filter on, a director also hides Mumbai's smallest member by hand. Which total still reads Rs 1,56,790? a) SUBTOTAL(109) only; b) SUMIFS on the city only; c) both; d) neither.</a:t>
+            </a:r>
+          </a:p>
+        </p:txBody>
+      </p:sp>
+      <p:sp>
+        <p:nvSpPr>
+          <p:cNvPr id="14" name="Oval 13"/>
+          <p:cNvSpPr/>
+          <p:nvPr/>
+        </p:nvSpPr>
+        <p:spPr>
+          <a:xfrm>
+            <a:off x="530352" y="6492240"/>
+            <a:ext cx="64008" cy="64008"/>
+          </a:xfrm>
+          <a:prstGeom prst="ellipse">
+            <a:avLst/>
+          </a:prstGeom>
+          <a:solidFill>
+            <a:srgbClr val="5B3FD6"/>
+          </a:solidFill>
+          <a:ln>
+            <a:noFill/>
+          </a:ln>
+          <a:effectLst/>
+        </p:spPr>
+        <p:style>
+          <a:lnRef idx="1">
+            <a:schemeClr val="accent1"/>
+          </a:lnRef>
+          <a:fillRef idx="3">
+            <a:schemeClr val="accent1"/>
+          </a:fillRef>
+          <a:effectRef idx="2">
+            <a:schemeClr val="accent1"/>
+          </a:effectRef>
+          <a:fontRef idx="minor">
+            <a:schemeClr val="lt1"/>
+          </a:fontRef>
+        </p:style>
+        <p:txBody>
+          <a:bodyPr rtlCol="0" anchor="ctr" wrap="square"/>
+          <a:lstStyle/>
+          <a:p>
+            <a:pPr algn="ctr"/>
+          </a:p>
+        </p:txBody>
+      </p:sp>
+      <p:sp>
+        <p:nvSpPr>
+          <p:cNvPr id="15" name="TextBox 14"/>
           <p:cNvSpPr txBox="1"/>
           <p:nvPr/>
         </p:nvSpPr>
@@ -9069,7 +9548,7 @@
       </p:sp>
       <p:sp>
         <p:nvSpPr>
-          <p:cNvPr id="13" name="Oval 12"/>
+          <p:cNvPr id="16" name="Oval 15"/>
           <p:cNvSpPr/>
           <p:nvPr/>
         </p:nvSpPr>
@@ -9113,7 +9592,7 @@
       </p:sp>
       <p:sp>
         <p:nvSpPr>
-          <p:cNvPr id="14" name="TextBox 13"/>
+          <p:cNvPr id="17" name="TextBox 16"/>
           <p:cNvSpPr txBox="1"/>
           <p:nvPr/>
         </p:nvSpPr>
@@ -9148,7 +9627,7 @@
       </p:sp>
       <p:sp>
         <p:nvSpPr>
-          <p:cNvPr id="15" name="Oval 14"/>
+          <p:cNvPr id="18" name="Oval 17"/>
           <p:cNvSpPr/>
           <p:nvPr/>
         </p:nvSpPr>
@@ -9192,7 +9671,7 @@
       </p:sp>
       <p:sp>
         <p:nvSpPr>
-          <p:cNvPr id="16" name="TextBox 15"/>
+          <p:cNvPr id="19" name="TextBox 18"/>
           <p:cNvSpPr txBox="1"/>
           <p:nvPr/>
         </p:nvSpPr>
@@ -9227,7 +9706,7 @@
       </p:sp>
       <p:sp>
         <p:nvSpPr>
-          <p:cNvPr id="17" name="Oval 16"/>
+          <p:cNvPr id="20" name="Oval 19"/>
           <p:cNvSpPr/>
           <p:nvPr/>
         </p:nvSpPr>
@@ -9271,7 +9750,7 @@
       </p:sp>
       <p:sp>
         <p:nvSpPr>
-          <p:cNvPr id="18" name="TextBox 17"/>
+          <p:cNvPr id="21" name="TextBox 20"/>
           <p:cNvSpPr txBox="1"/>
           <p:nvPr/>
         </p:nvSpPr>
@@ -9306,7 +9785,7 @@
       </p:sp>
       <p:sp>
         <p:nvSpPr>
-          <p:cNvPr id="19" name="Oval 18"/>
+          <p:cNvPr id="22" name="Oval 21"/>
           <p:cNvSpPr/>
           <p:nvPr/>
         </p:nvSpPr>
@@ -9350,7 +9829,7 @@
       </p:sp>
       <p:sp>
         <p:nvSpPr>
-          <p:cNvPr id="20" name="TextBox 19"/>
+          <p:cNvPr id="23" name="TextBox 22"/>
           <p:cNvSpPr txBox="1"/>
           <p:nvPr/>
         </p:nvSpPr>
@@ -9385,7 +9864,7 @@
       </p:sp>
       <p:sp>
         <p:nvSpPr>
-          <p:cNvPr id="21" name="Oval 20"/>
+          <p:cNvPr id="24" name="Oval 23"/>
           <p:cNvSpPr/>
           <p:nvPr/>
         </p:nvSpPr>
@@ -9429,7 +9908,7 @@
       </p:sp>
       <p:sp>
         <p:nvSpPr>
-          <p:cNvPr id="22" name="TextBox 21"/>
+          <p:cNvPr id="25" name="TextBox 24"/>
           <p:cNvSpPr txBox="1"/>
           <p:nvPr/>
         </p:nvSpPr>
@@ -9464,7 +9943,7 @@
       </p:sp>
       <p:sp>
         <p:nvSpPr>
-          <p:cNvPr id="23" name="TextBox 22"/>
+          <p:cNvPr id="26" name="TextBox 25"/>
           <p:cNvSpPr txBox="1"/>
           <p:nvPr/>
         </p:nvSpPr>
@@ -9733,35 +10212,242 @@
                 </a:solidFill>
                 <a:latin typeface="Calibri"/>
               </a:rPr>
-              <a:t>Does a total that ignores the filter altogether agree with the foot?</a:t>
-            </a:r>
-          </a:p>
-        </p:txBody>
-      </p:sp>
-      <p:pic>
-        <p:nvPicPr>
-          <p:cNvPr id="9" name="mermaid diagram" descr="93eb2a503635aabd.png"/>
-          <p:cNvPicPr>
-            <a:picLocks noChangeAspect="1"/>
-          </p:cNvPicPr>
-          <p:nvPr/>
-        </p:nvPicPr>
-        <p:blipFill>
-          <a:blip r:embed="rId5"/>
-          <a:stretch>
-            <a:fillRect/>
-          </a:stretch>
-        </p:blipFill>
-        <p:spPr>
-          <a:xfrm>
-            <a:off x="3759841" y="1956816"/>
-            <a:ext cx="4672012" cy="2043112"/>
-          </a:xfrm>
-          <a:prstGeom prst="rect">
-            <a:avLst/>
-          </a:prstGeom>
-        </p:spPr>
-      </p:pic>
+              <a:t>Does a total that reads the city, and never the screen, agree with the foot?</a:t>
+            </a:r>
+          </a:p>
+        </p:txBody>
+      </p:sp>
+      <p:graphicFrame>
+        <p:nvGraphicFramePr>
+          <p:cNvPr id="9" name="Table 8"/>
+          <p:cNvGraphicFramePr>
+            <a:graphicFrameLocks noGrp="1"/>
+          </p:cNvGraphicFramePr>
+          <p:nvPr/>
+        </p:nvGraphicFramePr>
+        <p:xfrm>
+          <a:off x="530352" y="1956816"/>
+          <a:ext cx="11130989" cy="1109472"/>
+        </p:xfrm>
+        <a:graphic>
+          <a:graphicData uri="http://schemas.openxmlformats.org/drawingml/2006/table">
+            <a:tbl>
+              <a:tblPr firstRow="0" bandRow="0">
+                <a:tableStyleId>{2D5ABB26-0587-4C30-8999-92F81FD0307C}</a:tableStyleId>
+              </a:tblPr>
+              <a:tblGrid>
+                <a:gridCol w="5258179"/>
+                <a:gridCol w="3520324"/>
+                <a:gridCol w="2352486"/>
+              </a:tblGrid>
+              <a:tr h="369824">
+                <a:tc>
+                  <a:txBody>
+                    <a:bodyPr/>
+                    <a:lstStyle/>
+                    <a:p>
+                      <a:r>
+                        <a:rPr sz="1450" b="1" i="0">
+                          <a:solidFill>
+                            <a:srgbClr val="FFFFFF"/>
+                          </a:solidFill>
+                          <a:latin typeface="Calibri"/>
+                        </a:rPr>
+                        <a:t>What the director has done</a:t>
+                      </a:r>
+                    </a:p>
+                  </a:txBody>
+                  <a:tcPr marL="101600" marR="101600" marT="38100" marB="38100" anchor="ctr">
+                    <a:solidFill>
+                      <a:srgbClr val="1A0F5C"/>
+                    </a:solidFill>
+                  </a:tcPr>
+                </a:tc>
+                <a:tc>
+                  <a:txBody>
+                    <a:bodyPr/>
+                    <a:lstStyle/>
+                    <a:p>
+                      <a:r>
+                        <a:rPr sz="1450" b="1" i="0">
+                          <a:solidFill>
+                            <a:srgbClr val="FFFFFF"/>
+                          </a:solidFill>
+                          <a:latin typeface="Calibri"/>
+                        </a:rPr>
+                        <a:t>SUBTOTAL(109), the screen</a:t>
+                      </a:r>
+                    </a:p>
+                  </a:txBody>
+                  <a:tcPr marL="101600" marR="101600" marT="38100" marB="38100" anchor="ctr">
+                    <a:solidFill>
+                      <a:srgbClr val="1A0F5C"/>
+                    </a:solidFill>
+                  </a:tcPr>
+                </a:tc>
+                <a:tc>
+                  <a:txBody>
+                    <a:bodyPr/>
+                    <a:lstStyle/>
+                    <a:p>
+                      <a:r>
+                        <a:rPr sz="1450" b="1" i="0">
+                          <a:solidFill>
+                            <a:srgbClr val="FFFFFF"/>
+                          </a:solidFill>
+                          <a:latin typeface="Calibri"/>
+                        </a:rPr>
+                        <a:t>SUMIFS, the city</a:t>
+                      </a:r>
+                    </a:p>
+                  </a:txBody>
+                  <a:tcPr marL="101600" marR="101600" marT="38100" marB="38100" anchor="ctr">
+                    <a:solidFill>
+                      <a:srgbClr val="1A0F5C"/>
+                    </a:solidFill>
+                  </a:tcPr>
+                </a:tc>
+              </a:tr>
+              <a:tr h="369824">
+                <a:tc>
+                  <a:txBody>
+                    <a:bodyPr/>
+                    <a:lstStyle/>
+                    <a:p>
+                      <a:r>
+                        <a:rPr sz="1400" b="0" i="0">
+                          <a:solidFill>
+                            <a:srgbClr val="1A1440"/>
+                          </a:solidFill>
+                          <a:latin typeface="Calibri"/>
+                        </a:rPr>
+                        <a:t>Filtered to Mumbai</a:t>
+                      </a:r>
+                    </a:p>
+                  </a:txBody>
+                  <a:tcPr marL="101600" marR="101600" marT="38100" marB="38100" anchor="ctr">
+                    <a:solidFill>
+                      <a:srgbClr val="FFFFFF"/>
+                    </a:solidFill>
+                  </a:tcPr>
+                </a:tc>
+                <a:tc>
+                  <a:txBody>
+                    <a:bodyPr/>
+                    <a:lstStyle/>
+                    <a:p>
+                      <a:r>
+                        <a:rPr sz="1400" b="0" i="0">
+                          <a:solidFill>
+                            <a:srgbClr val="1A1440"/>
+                          </a:solidFill>
+                          <a:latin typeface="Calibri"/>
+                        </a:rPr>
+                        <a:t>Rs 1,56,790</a:t>
+                      </a:r>
+                    </a:p>
+                  </a:txBody>
+                  <a:tcPr marL="101600" marR="101600" marT="38100" marB="38100" anchor="ctr">
+                    <a:solidFill>
+                      <a:srgbClr val="FFFFFF"/>
+                    </a:solidFill>
+                  </a:tcPr>
+                </a:tc>
+                <a:tc>
+                  <a:txBody>
+                    <a:bodyPr/>
+                    <a:lstStyle/>
+                    <a:p>
+                      <a:r>
+                        <a:rPr sz="1400" b="0" i="0">
+                          <a:solidFill>
+                            <a:srgbClr val="1A1440"/>
+                          </a:solidFill>
+                          <a:latin typeface="Calibri"/>
+                        </a:rPr>
+                        <a:t>Rs 1,56,790</a:t>
+                      </a:r>
+                    </a:p>
+                  </a:txBody>
+                  <a:tcPr marL="101600" marR="101600" marT="38100" marB="38100" anchor="ctr">
+                    <a:solidFill>
+                      <a:srgbClr val="FFFFFF"/>
+                    </a:solidFill>
+                  </a:tcPr>
+                </a:tc>
+              </a:tr>
+              <a:tr h="369824">
+                <a:tc>
+                  <a:txBody>
+                    <a:bodyPr/>
+                    <a:lstStyle/>
+                    <a:p>
+                      <a:r>
+                        <a:rPr sz="1400" b="0" i="0">
+                          <a:solidFill>
+                            <a:srgbClr val="1A1440"/>
+                          </a:solidFill>
+                          <a:latin typeface="Calibri"/>
+                        </a:rPr>
+                        <a:t>Filtered, and one Mumbai row hidden by hand</a:t>
+                      </a:r>
+                    </a:p>
+                  </a:txBody>
+                  <a:tcPr marL="101600" marR="101600" marT="38100" marB="38100" anchor="ctr">
+                    <a:solidFill>
+                      <a:srgbClr val="F4F2FA"/>
+                    </a:solidFill>
+                  </a:tcPr>
+                </a:tc>
+                <a:tc>
+                  <a:txBody>
+                    <a:bodyPr/>
+                    <a:lstStyle/>
+                    <a:p>
+                      <a:r>
+                        <a:rPr sz="1400" b="0" i="0">
+                          <a:solidFill>
+                            <a:srgbClr val="1A1440"/>
+                          </a:solidFill>
+                          <a:latin typeface="Calibri"/>
+                        </a:rPr>
+                        <a:t>Rs 1,47,400</a:t>
+                      </a:r>
+                    </a:p>
+                  </a:txBody>
+                  <a:tcPr marL="101600" marR="101600" marT="38100" marB="38100" anchor="ctr">
+                    <a:solidFill>
+                      <a:srgbClr val="F4F2FA"/>
+                    </a:solidFill>
+                  </a:tcPr>
+                </a:tc>
+                <a:tc>
+                  <a:txBody>
+                    <a:bodyPr/>
+                    <a:lstStyle/>
+                    <a:p>
+                      <a:r>
+                        <a:rPr sz="1400" b="0" i="0">
+                          <a:solidFill>
+                            <a:srgbClr val="1A1440"/>
+                          </a:solidFill>
+                          <a:latin typeface="Calibri"/>
+                        </a:rPr>
+                        <a:t>Rs 1,56,790</a:t>
+                      </a:r>
+                    </a:p>
+                  </a:txBody>
+                  <a:tcPr marL="101600" marR="101600" marT="38100" marB="38100" anchor="ctr">
+                    <a:solidFill>
+                      <a:srgbClr val="F4F2FA"/>
+                    </a:solidFill>
+                  </a:tcPr>
+                </a:tc>
+              </a:tr>
+            </a:tbl>
+          </a:graphicData>
+        </a:graphic>
+      </p:graphicFrame>
       <p:sp>
         <p:nvSpPr>
           <p:cNvPr id="10" name="TextBox 9"/>
@@ -9770,8 +10456,8 @@
         </p:nvSpPr>
         <p:spPr>
           <a:xfrm>
-            <a:off x="530352" y="4146232"/>
-            <a:ext cx="11130991" cy="772160"/>
+            <a:off x="530352" y="3322320"/>
+            <a:ext cx="11130991" cy="1324864"/>
           </a:xfrm>
           <a:prstGeom prst="rect">
             <a:avLst/>
@@ -9796,7 +10482,7 @@
                 </a:solidFill>
                 <a:latin typeface="Calibri"/>
               </a:rPr>
-              <a:t>=SUMIFS(E2:E51, C2:C51, "Mumbai") reads the whole list and picks Mumbai by its city, whatever the screen shows. It gives Rs 1,56,790, the same as the visible foot.</a:t>
+              <a:t>The answer is b. =SUMIFS(E2:E51, C2:C51, "Mumbai") reads the whole list and picks Mumbai by its city, whatever the screen shows. With only the filter on, the two agree; once Mumbai's smallest member, Rs 9,390, is also hidden by hand, the foot drops and SUMIFS does not, so a gap between them says the screen shows less than the whole city.</a:t>
             </a:r>
           </a:p>
         </p:txBody>
@@ -10897,7 +11583,7 @@
                 </a:solidFill>
                 <a:latin typeface="Calibri"/>
               </a:rPr>
-              <a:t>Question. </a:t>
+              <a:t>Predict before you run. </a:t>
             </a:r>
             <a:r>
               <a:rPr sz="1500" b="0" i="0">
@@ -11719,7 +12405,7 @@
                 </a:solidFill>
                 <a:latin typeface="Calibri"/>
               </a:rPr>
-              <a:t>The answer is b: Rs 500 times the eleven on screen; the whole list would cost Rs 25,000. The director types Rs 750 and the cost becomes Rs 8,250 in front of the room, while the list's figures never change: the assumption sits beside them, never over them.</a:t>
+              <a:t>The answer is b: Rs 500 times the eleven on screen; the whole list would cost Rs 25,000. The director types Rs 750 and the cost becomes Rs 8,250 in front of the room. The list's figures stay as they were, because the assumption sits in its own yellow cell and the list keeps its formulas.</a:t>
             </a:r>
           </a:p>
         </p:txBody>
@@ -13032,7 +13718,7 @@
                 </a:solidFill>
                 <a:latin typeface="Calibri"/>
               </a:rPr>
-              <a:t>Question. </a:t>
+              <a:t>Predict before you run. </a:t>
             </a:r>
             <a:r>
               <a:rPr sz="1500" b="0" i="0">
@@ -13854,7 +14540,7 @@
                 </a:solidFill>
                 <a:latin typeface="Calibri"/>
               </a:rPr>
-              <a:t>The answer is b: "Hold the protect list; ship the rest." A figure typed over a formula holds the whole workbook, since nobody can say which other numbers it moved. A formula recalculating is never the same as the number being right, so the release reads the checks and nothing else.</a:t>
+              <a:t>The answer is b: "Hold the protect list; ship the rest." A figure typed over a formula holds the whole workbook, since nobody can say which other numbers it moved. Formulas recalculate whether or not their inputs tie, so the release reads the checks and nothing else.</a:t>
             </a:r>
           </a:p>
         </p:txBody>
@@ -14604,7 +15290,7 @@
                 </a:solidFill>
                 <a:latin typeface="Calibri"/>
               </a:rPr>
-              <a:t>What did chapter 6 answer, question by question?</a:t>
+              <a:t>What can a director break, and which checks catch it?</a:t>
             </a:r>
           </a:p>
         </p:txBody>
@@ -14618,8 +15304,8 @@
           <p:nvPr/>
         </p:nvGraphicFramePr>
         <p:xfrm>
-          <a:off x="530352" y="1819656"/>
-          <a:ext cx="11130991" cy="2176272"/>
+          <a:off x="530352" y="1794764"/>
+          <a:ext cx="11130990" cy="2226056"/>
         </p:xfrm>
         <a:graphic>
           <a:graphicData uri="http://schemas.openxmlformats.org/drawingml/2006/table">
@@ -14628,17 +15314,17 @@
                 <a:tableStyleId>{2D5ABB26-0587-4C30-8999-92F81FD0307C}</a:tableStyleId>
               </a:tblPr>
               <a:tblGrid>
-                <a:gridCol w="3081542"/>
-                <a:gridCol w="8049449"/>
+                <a:gridCol w="3389936"/>
+                <a:gridCol w="7741054"/>
               </a:tblGrid>
-              <a:tr h="310896">
+              <a:tr h="318008">
                 <a:tc>
                   <a:txBody>
                     <a:bodyPr/>
                     <a:lstStyle/>
                     <a:p>
                       <a:r>
-                        <a:rPr sz="950" b="1" i="0">
+                        <a:rPr sz="1150" b="1" i="0">
                           <a:solidFill>
                             <a:srgbClr val="FFFFFF"/>
                           </a:solidFill>
@@ -14660,7 +15346,7 @@
                     <a:lstStyle/>
                     <a:p>
                       <a:r>
-                        <a:rPr sz="950" b="1" i="0">
+                        <a:rPr sz="1150" b="1" i="0">
                           <a:solidFill>
                             <a:srgbClr val="FFFFFF"/>
                           </a:solidFill>
@@ -14677,20 +15363,20 @@
                   </a:tcPr>
                 </a:tc>
               </a:tr>
-              <a:tr h="310896">
+              <a:tr h="318008">
                 <a:tc>
                   <a:txBody>
                     <a:bodyPr/>
                     <a:lstStyle/>
                     <a:p>
                       <a:r>
-                        <a:rPr sz="900" b="0" i="0">
+                        <a:rPr sz="1100" b="0" i="0">
                           <a:solidFill>
                             <a:srgbClr val="1A1440"/>
                           </a:solidFill>
                           <a:latin typeface="Calibri"/>
                         </a:rPr>
-                        <a:t>What will they do?</a:t>
+                        <a:t>How to protect it?</a:t>
                       </a:r>
                     </a:p>
                   </a:txBody>
@@ -14706,13 +15392,13 @@
                     <a:lstStyle/>
                     <a:p>
                       <a:r>
-                        <a:rPr sz="900" b="0" i="0">
+                        <a:rPr sz="1100" b="0" i="0">
                           <a:solidFill>
                             <a:srgbClr val="1A1440"/>
                           </a:solidFill>
                           <a:latin typeface="Calibri"/>
                         </a:rPr>
-                        <a:t>Filter, sort, type over, change inputs, paste exports</a:t>
+                        <a:t>c: yellow inputs, formulas, a Checks tab</a:t>
                       </a:r>
                     </a:p>
                   </a:txBody>
@@ -14723,20 +15409,20 @@
                   </a:tcPr>
                 </a:tc>
               </a:tr>
-              <a:tr h="310896">
+              <a:tr h="318008">
                 <a:tc>
                   <a:txBody>
                     <a:bodyPr/>
                     <a:lstStyle/>
                     <a:p>
                       <a:r>
-                        <a:rPr sz="900" b="0" i="0">
+                        <a:rPr sz="1100" b="0" i="0">
                           <a:solidFill>
                             <a:srgbClr val="1A1440"/>
                           </a:solidFill>
                           <a:latin typeface="Calibri"/>
                         </a:rPr>
-                        <a:t>How to protect it?</a:t>
+                        <a:t>What will they do?</a:t>
                       </a:r>
                     </a:p>
                   </a:txBody>
@@ -14752,13 +15438,13 @@
                     <a:lstStyle/>
                     <a:p>
                       <a:r>
-                        <a:rPr sz="900" b="0" i="0">
+                        <a:rPr sz="1100" b="0" i="0">
                           <a:solidFill>
                             <a:srgbClr val="1A1440"/>
                           </a:solidFill>
                           <a:latin typeface="Calibri"/>
                         </a:rPr>
-                        <a:t>c: yellow inputs, formulas, a Checks tab</a:t>
+                        <a:t>Filter, sort, type over, change inputs, paste</a:t>
                       </a:r>
                     </a:p>
                   </a:txBody>
@@ -14769,14 +15455,14 @@
                   </a:tcPr>
                 </a:tc>
               </a:tr>
-              <a:tr h="310896">
+              <a:tr h="318008">
                 <a:tc>
                   <a:txBody>
                     <a:bodyPr/>
                     <a:lstStyle/>
                     <a:p>
                       <a:r>
-                        <a:rPr sz="900" b="0" i="0">
+                        <a:rPr sz="1100" b="0" i="0">
                           <a:solidFill>
                             <a:srgbClr val="1A1440"/>
                           </a:solidFill>
@@ -14798,7 +15484,7 @@
                     <a:lstStyle/>
                     <a:p>
                       <a:r>
-                        <a:rPr sz="900" b="0" i="0">
+                        <a:rPr sz="1100" b="0" i="0">
                           <a:solidFill>
                             <a:srgbClr val="1A1440"/>
                           </a:solidFill>
@@ -14815,14 +15501,14 @@
                   </a:tcPr>
                 </a:tc>
               </a:tr>
-              <a:tr h="310896">
+              <a:tr h="318008">
                 <a:tc>
                   <a:txBody>
                     <a:bodyPr/>
                     <a:lstStyle/>
                     <a:p>
                       <a:r>
-                        <a:rPr sz="900" b="0" i="0">
+                        <a:rPr sz="1100" b="0" i="0">
                           <a:solidFill>
                             <a:srgbClr val="1A1440"/>
                           </a:solidFill>
@@ -14844,13 +15530,13 @@
                     <a:lstStyle/>
                     <a:p>
                       <a:r>
-                        <a:rPr sz="900" b="0" i="0">
+                        <a:rPr sz="1100" b="0" i="0">
                           <a:solidFill>
                             <a:srgbClr val="1A1440"/>
                           </a:solidFill>
                           <a:latin typeface="Calibri"/>
                         </a:rPr>
-                        <a:t>SUBTOTAL(109) Rs 1,56,790; SUMIFS agrees</a:t>
+                        <a:t>SUBTOTAL(109), Rs 1,56,790 for eleven</a:t>
                       </a:r>
                     </a:p>
                   </a:txBody>
@@ -14861,14 +15547,14 @@
                   </a:tcPr>
                 </a:tc>
               </a:tr>
-              <a:tr h="310896">
+              <a:tr h="318008">
                 <a:tc>
                   <a:txBody>
                     <a:bodyPr/>
                     <a:lstStyle/>
                     <a:p>
                       <a:r>
-                        <a:rPr sz="900" b="0" i="0">
+                        <a:rPr sz="1100" b="0" i="0">
                           <a:solidFill>
                             <a:srgbClr val="1A1440"/>
                           </a:solidFill>
@@ -14890,13 +15576,13 @@
                     <a:lstStyle/>
                     <a:p>
                       <a:r>
-                        <a:rPr sz="900" b="0" i="0">
+                        <a:rPr sz="1100" b="0" i="0">
                           <a:solidFill>
                             <a:srgbClr val="1A1440"/>
                           </a:solidFill>
                           <a:latin typeface="Calibri"/>
                         </a:rPr>
-                        <a:t>A yellow input: Rs 500 costs Rs 5,500 for Mumbai</a:t>
+                        <a:t>A yellow input: Rs 5,500 for Mumbai</a:t>
                       </a:r>
                     </a:p>
                   </a:txBody>
@@ -14907,14 +15593,14 @@
                   </a:tcPr>
                 </a:tc>
               </a:tr>
-              <a:tr h="310896">
+              <a:tr h="318008">
                 <a:tc>
                   <a:txBody>
                     <a:bodyPr/>
                     <a:lstStyle/>
                     <a:p>
                       <a:r>
-                        <a:rPr sz="900" b="0" i="0">
+                        <a:rPr sz="1100" b="0" i="0">
                           <a:solidFill>
                             <a:srgbClr val="1A1440"/>
                           </a:solidFill>
@@ -14936,7 +15622,7 @@
                     <a:lstStyle/>
                     <a:p>
                       <a:r>
-                        <a:rPr sz="900" b="0" i="0">
+                        <a:rPr sz="1100" b="0" i="0">
                           <a:solidFill>
                             <a:srgbClr val="1A1440"/>
                           </a:solidFill>
@@ -14965,7 +15651,7 @@
         </p:nvSpPr>
         <p:spPr>
           <a:xfrm>
-            <a:off x="530352" y="4251960"/>
+            <a:off x="530352" y="4276852"/>
             <a:ext cx="11130991" cy="822960"/>
           </a:xfrm>
           <a:prstGeom prst="roundRect">
@@ -15019,7 +15705,7 @@
         </p:nvSpPr>
         <p:spPr>
           <a:xfrm>
-            <a:off x="758952" y="4434840"/>
+            <a:off x="758952" y="4459732"/>
             <a:ext cx="457200" cy="457200"/>
           </a:xfrm>
           <a:prstGeom prst="ellipse">
@@ -15071,7 +15757,7 @@
         </p:blipFill>
         <p:spPr>
           <a:xfrm>
-            <a:off x="868680" y="4544568"/>
+            <a:off x="868680" y="4569460"/>
             <a:ext cx="237744" cy="237744"/>
           </a:xfrm>
           <a:prstGeom prst="rect">
@@ -15087,7 +15773,7 @@
         </p:nvSpPr>
         <p:spPr>
           <a:xfrm>
-            <a:off x="1399031" y="4398264"/>
+            <a:off x="1399031" y="4423156"/>
             <a:ext cx="9987991" cy="160401"/>
           </a:xfrm>
           <a:prstGeom prst="rect">
@@ -15122,7 +15808,7 @@
         </p:nvSpPr>
         <p:spPr>
           <a:xfrm>
-            <a:off x="1399031" y="4617720"/>
+            <a:off x="1399031" y="4642612"/>
             <a:ext cx="9987991" cy="384048"/>
           </a:xfrm>
           <a:prstGeom prst="rect">
@@ -15137,13 +15823,13 @@
           <a:lstStyle/>
           <a:p>
             <a:r>
-              <a:rPr sz="1000" b="0" i="0">
+              <a:rPr sz="1100" b="0" i="0">
                 <a:solidFill>
                   <a:srgbClr val="1A1440"/>
                 </a:solidFill>
                 <a:latin typeface="Calibri"/>
               </a:rPr>
-              <a:t>"A director who filters, sorts or asks a what-if should see the right numbers move, and see a wrong one turn red before anyone reads it out."</a:t>
+              <a:t>"A director who filters, sorts or asks a what-if should see the right numbers move and a wrong one turn red."</a:t>
             </a:r>
           </a:p>
         </p:txBody>
@@ -15156,7 +15842,7 @@
         </p:nvSpPr>
         <p:spPr>
           <a:xfrm>
-            <a:off x="530352" y="5239512"/>
+            <a:off x="530352" y="5264404"/>
             <a:ext cx="11130991" cy="822960"/>
           </a:xfrm>
           <a:prstGeom prst="roundRect">
@@ -15210,7 +15896,7 @@
         </p:nvSpPr>
         <p:spPr>
           <a:xfrm>
-            <a:off x="758952" y="5422392"/>
+            <a:off x="758952" y="5447284"/>
             <a:ext cx="457200" cy="457200"/>
           </a:xfrm>
           <a:prstGeom prst="ellipse">
@@ -15262,7 +15948,7 @@
         </p:blipFill>
         <p:spPr>
           <a:xfrm>
-            <a:off x="868680" y="5532120"/>
+            <a:off x="868680" y="5557012"/>
             <a:ext cx="237744" cy="237744"/>
           </a:xfrm>
           <a:prstGeom prst="rect">
@@ -15278,7 +15964,7 @@
         </p:nvSpPr>
         <p:spPr>
           <a:xfrm>
-            <a:off x="1399031" y="5385816"/>
+            <a:off x="1399031" y="5410708"/>
             <a:ext cx="9987991" cy="160401"/>
           </a:xfrm>
           <a:prstGeom prst="rect">
@@ -15313,7 +15999,7 @@
         </p:nvSpPr>
         <p:spPr>
           <a:xfrm>
-            <a:off x="1399031" y="5605272"/>
+            <a:off x="1399031" y="5630164"/>
             <a:ext cx="9987991" cy="384048"/>
           </a:xfrm>
           <a:prstGeom prst="rect">
@@ -15328,7 +16014,7 @@
           <a:lstStyle/>
           <a:p>
             <a:r>
-              <a:rPr sz="1000" b="0" i="0">
+              <a:rPr sz="1100" b="0" i="0">
                 <a:solidFill>
                   <a:srgbClr val="1A1440"/>
                 </a:solidFill>
@@ -16484,7 +17170,7 @@
                 </a:solidFill>
                 <a:latin typeface="Calibri"/>
               </a:rPr>
-              <a:t>Week 2, Day 5. What can a director open, change and still trust?</a:t>
+              <a:t>Week 2, Day 5. Can a director change it and still trust it?</a:t>
             </a:r>
           </a:p>
         </p:txBody>
@@ -17110,7 +17796,7 @@
                           </a:solidFill>
                           <a:latin typeface="Calibri"/>
                         </a:rPr>
-                        <a:t>12</a:t>
+                        <a:t>10</a:t>
                       </a:r>
                     </a:p>
                   </a:txBody>
@@ -17292,7 +17978,7 @@
                           </a:solidFill>
                           <a:latin typeface="Calibri"/>
                         </a:rPr>
-                        <a:t>What ships on Monday, and what is held?</a:t>
+                        <a:t>What ships on Monday, and what, if anything, is held?</a:t>
                       </a:r>
                     </a:p>
                   </a:txBody>
@@ -17314,7 +18000,7 @@
                           </a:solidFill>
                           <a:latin typeface="Calibri"/>
                         </a:rPr>
-                        <a:t>5</a:t>
+                        <a:t>10</a:t>
                       </a:r>
                     </a:p>
                   </a:txBody>
@@ -18542,7 +19228,7 @@
                 </a:solidFill>
                 <a:latin typeface="Calibri"/>
               </a:rPr>
-              <a:t>Week 2, Day 5. What can a director open, change and still trust?</a:t>
+              <a:t>Week 2, Day 5. Can a director change it and still trust it?</a:t>
             </a:r>
           </a:p>
         </p:txBody>
@@ -19978,7 +20664,7 @@
                 </a:solidFill>
                 <a:latin typeface="Calibri"/>
               </a:rPr>
-              <a:t>A deliverable that fails its check is held with its reason, never shipped with a footnote.</a:t>
+              <a:t>"A deliverable that fails its check is held, and the note says why."</a:t>
             </a:r>
           </a:p>
         </p:txBody>
@@ -21128,7 +21814,7 @@
                 </a:solidFill>
                 <a:latin typeface="Calibri"/>
               </a:rPr>
-              <a:t>Week 2, Day 5. What can a director open, change and still trust?</a:t>
+              <a:t>Week 2, Day 5. Can a director change it and still trust it?</a:t>
             </a:r>
           </a:p>
         </p:txBody>
@@ -22725,7 +23411,7 @@
                 </a:solidFill>
                 <a:latin typeface="Calibri"/>
               </a:rPr>
-              <a:t>The tree and the card tie; the list comes from a different export. If that export does not tie, what does the Checks tab hold?</a:t>
+              <a:t>If the list's export does not tie while the tree and the card do, what does the Checks tab hold?</a:t>
             </a:r>
           </a:p>
         </p:txBody>
@@ -22877,7 +23563,7 @@
                 </a:solidFill>
                 <a:latin typeface="Calibri"/>
               </a:rPr>
-              <a:t>Question. </a:t>
+              <a:t>Predict before you run. </a:t>
             </a:r>
             <a:r>
               <a:rPr sz="1500" b="0" i="0">
@@ -22886,7 +23572,7 @@
                 </a:solidFill>
                 <a:latin typeface="Calibri"/>
               </a:rPr>
-              <a:t>Which part does the Checks tab hold, as a letter?</a:t>
+              <a:t>Which part does the Checks tab hold?</a:t>
             </a:r>
           </a:p>
         </p:txBody>
@@ -23699,7 +24385,7 @@
                 </a:solidFill>
                 <a:latin typeface="Calibri"/>
               </a:rPr>
-              <a:t>The answer is b. A list built on a table that does not tie waits, with a note to the data platform lead that names the gap and asks for the export to be rerun. Option d is the afternoon's trap: formulas recalculating is not the same as numbers being right.</a:t>
+              <a:t>The answer is b. A list built on a table that does not tie waits, with a note to the data platform lead that names the gap and asks for the export to be rerun. Option d is the afternoon's trap: formulas recalculate whether or not their inputs tie.</a:t>
             </a:r>
           </a:p>
         </p:txBody>
@@ -24849,7 +25535,7 @@
                 </a:solidFill>
                 <a:latin typeface="Calibri"/>
               </a:rPr>
-              <a:t>Week 2, Day 5. What can a director open, change and still trust?</a:t>
+              <a:t>Week 2, Day 5. Can a director change it and still trust it?</a:t>
             </a:r>
           </a:p>
         </p:txBody>
@@ -25090,7 +25776,7 @@
                 </a:solidFill>
                 <a:latin typeface="Georgia"/>
               </a:rPr>
-              <a:t>Answer it by saying yes to the question</a:t>
+              <a:t>The director asks for five lakh in the room</a:t>
             </a:r>
           </a:p>
         </p:txBody>
@@ -25125,7 +25811,7 @@
                 </a:solidFill>
                 <a:latin typeface="Calibri"/>
               </a:rPr>
-              <a:t>What does the director ask, in the room, with the sheet on the projector?</a:t>
+              <a:t>What does the director ask, with the sheet on the projector?</a:t>
             </a:r>
           </a:p>
         </p:txBody>
@@ -26981,7 +27667,7 @@
                 </a:solidFill>
                 <a:latin typeface="Calibri"/>
               </a:rPr>
-              <a:t>The question is legitimate; the edit is not. Where does the director's number go?</a:t>
+              <a:t>Where does the director's five lakh go, so the card shows it and the source stays Finance's?</a:t>
             </a:r>
           </a:p>
         </p:txBody>
@@ -27133,7 +27819,7 @@
                 </a:solidFill>
                 <a:latin typeface="Calibri"/>
               </a:rPr>
-              <a:t>Question. </a:t>
+              <a:t>Predict before you run. </a:t>
             </a:r>
             <a:r>
               <a:rPr sz="1500" b="0" i="0">
@@ -27142,7 +27828,7 @@
                 </a:solidFill>
                 <a:latin typeface="Calibri"/>
               </a:rPr>
-              <a:t>Where does it belong, as a letter?</a:t>
+              <a:t>Where does it belong?</a:t>
             </a:r>
           </a:p>
         </p:txBody>
@@ -28877,7 +29563,7 @@
                 </a:solidFill>
                 <a:latin typeface="Georgia"/>
               </a:rPr>
-              <a:t>Answer it in six steps, from the room to the release</a:t>
+              <a:t>The directors take the laptop in the room</a:t>
             </a:r>
           </a:p>
         </p:txBody>
@@ -28912,7 +29598,7 @@
                 </a:solidFill>
                 <a:latin typeface="Calibri"/>
               </a:rPr>
-              <a:t>Who needs the answer, and what must we find out on the way?</a:t>
+              <a:t>Who changes the workbook in the room, and which six questions make it safe to hand over?</a:t>
             </a:r>
           </a:p>
         </p:txBody>
@@ -29261,7 +29947,7 @@
                 </a:solidFill>
                 <a:latin typeface="Calibri"/>
               </a:rPr>
-              <a:t>What will they do?</a:t>
+              <a:t>How to protect it?</a:t>
             </a:r>
           </a:p>
         </p:txBody>
@@ -29275,7 +29961,7 @@
         <p:spPr>
           <a:xfrm>
             <a:off x="694944" y="4731512"/>
-            <a:ext cx="1373581" cy="366776"/>
+            <a:ext cx="1373581" cy="201676"/>
           </a:xfrm>
           <a:prstGeom prst="rect">
             <a:avLst/>
@@ -29296,7 +29982,7 @@
                 </a:solidFill>
                 <a:latin typeface="Calibri"/>
               </a:rPr>
-              <a:t>Five things a director does to a sheet.</a:t>
+              <a:t>Four ways, sized.</a:t>
             </a:r>
           </a:p>
         </p:txBody>
@@ -29464,7 +30150,7 @@
                 </a:solidFill>
                 <a:latin typeface="Calibri"/>
               </a:rPr>
-              <a:t>How to protect it?</a:t>
+              <a:t>What will they do?</a:t>
             </a:r>
           </a:p>
         </p:txBody>
@@ -29478,7 +30164,7 @@
         <p:spPr>
           <a:xfrm>
             <a:off x="2580589" y="4731512"/>
-            <a:ext cx="1373581" cy="201676"/>
+            <a:ext cx="1373581" cy="366776"/>
           </a:xfrm>
           <a:prstGeom prst="rect">
             <a:avLst/>
@@ -29499,7 +30185,7 @@
                 </a:solidFill>
                 <a:latin typeface="Calibri"/>
               </a:rPr>
-              <a:t>Four ways, sized.</a:t>
+              <a:t>Five things a director does to a sheet.</a:t>
             </a:r>
           </a:p>
         </p:txBody>
@@ -31204,7 +31890,7 @@
         <p:spPr>
           <a:xfrm>
             <a:off x="530352" y="2843784"/>
-            <a:ext cx="3588410" cy="1076960"/>
+            <a:ext cx="3588410" cy="1249680"/>
           </a:xfrm>
           <a:prstGeom prst="roundRect">
             <a:avLst>
@@ -31407,7 +32093,7 @@
         <p:spPr>
           <a:xfrm>
             <a:off x="4301642" y="2843784"/>
-            <a:ext cx="3588410" cy="1076960"/>
+            <a:ext cx="3588410" cy="1249680"/>
           </a:xfrm>
           <a:prstGeom prst="roundRect">
             <a:avLst>
@@ -31610,7 +32296,7 @@
         <p:spPr>
           <a:xfrm>
             <a:off x="8072932" y="2843784"/>
-            <a:ext cx="3588410" cy="1076960"/>
+            <a:ext cx="3588410" cy="1249680"/>
           </a:xfrm>
           <a:prstGeom prst="roundRect">
             <a:avLst>
@@ -31705,7 +32391,7 @@
         <p:spPr>
           <a:xfrm>
             <a:off x="8237524" y="3277870"/>
-            <a:ext cx="3259226" cy="366776"/>
+            <a:ext cx="3259226" cy="531876"/>
           </a:xfrm>
           <a:prstGeom prst="rect">
             <a:avLst/>
@@ -31726,7 +32412,7 @@
                 </a:solidFill>
                 <a:latin typeface="Calibri"/>
               </a:rPr>
-              <a:t>Every refresh ties the sheet back to the warehouse, so a drift shows the same day.</a:t>
+              <a:t>The Checks tab compares the sheet with the warehouse's totals as it recalculates, so a drift shows at once.</a:t>
             </a:r>
           </a:p>
         </p:txBody>
@@ -31739,7 +32425,7 @@
         </p:nvSpPr>
         <p:spPr>
           <a:xfrm>
-            <a:off x="530352" y="4103624"/>
+            <a:off x="530352" y="4276344"/>
             <a:ext cx="11130991" cy="862584"/>
           </a:xfrm>
           <a:prstGeom prst="roundRect">
@@ -31793,7 +32479,7 @@
         </p:nvSpPr>
         <p:spPr>
           <a:xfrm>
-            <a:off x="758952" y="4306316"/>
+            <a:off x="758952" y="4479036"/>
             <a:ext cx="457200" cy="457200"/>
           </a:xfrm>
           <a:prstGeom prst="ellipse">
@@ -31845,7 +32531,7 @@
         </p:blipFill>
         <p:spPr>
           <a:xfrm>
-            <a:off x="868680" y="4416044"/>
+            <a:off x="868680" y="4588764"/>
             <a:ext cx="237744" cy="237744"/>
           </a:xfrm>
           <a:prstGeom prst="rect">
@@ -31861,7 +32547,7 @@
         </p:nvSpPr>
         <p:spPr>
           <a:xfrm>
-            <a:off x="1399031" y="4249928"/>
+            <a:off x="1399031" y="4422648"/>
             <a:ext cx="9987991" cy="160401"/>
           </a:xfrm>
           <a:prstGeom prst="rect">
@@ -31896,7 +32582,7 @@
         </p:nvSpPr>
         <p:spPr>
           <a:xfrm>
-            <a:off x="1399031" y="4469384"/>
+            <a:off x="1399031" y="4642104"/>
             <a:ext cx="9987991" cy="423672"/>
           </a:xfrm>
           <a:prstGeom prst="rect">
@@ -33067,7 +33753,7 @@
                 </a:solidFill>
                 <a:latin typeface="Calibri"/>
               </a:rPr>
-              <a:t>Week 2, Day 5. What can a director open, change and still trust?</a:t>
+              <a:t>Week 2, Day 5. Can a director change it and still trust it?</a:t>
             </a:r>
           </a:p>
         </p:txBody>
@@ -35930,7 +36616,7 @@
                 </a:solidFill>
                 <a:latin typeface="Calibri"/>
               </a:rPr>
-              <a:t>Week 2, Day 5. What can a director open, change and still trust?</a:t>
+              <a:t>Week 2, Day 5. Can a director change it and still trust it?</a:t>
             </a:r>
           </a:p>
         </p:txBody>
@@ -40749,7 +41435,7 @@
                 </a:solidFill>
                 <a:latin typeface="Calibri"/>
               </a:rPr>
-              <a:t>What is at stake, who is in the room, and what does a silent change cost?</a:t>
+              <a:t>What does a silent change in the room cost the head of Retail-Plus?</a:t>
             </a:r>
           </a:p>
         </p:txBody>
@@ -43301,7 +43987,7 @@
           <p:nvPr/>
         </p:nvGraphicFramePr>
         <p:xfrm>
-          <a:off x="530352" y="1956816"/>
+          <a:off x="530352" y="1890014"/>
           <a:ext cx="11130990" cy="2332736"/>
         </p:xfrm>
         <a:graphic>
@@ -43667,7 +44353,7 @@
         </p:nvSpPr>
         <p:spPr>
           <a:xfrm>
-            <a:off x="530352" y="4545584"/>
+            <a:off x="530352" y="4478782"/>
             <a:ext cx="11130991" cy="807720"/>
           </a:xfrm>
           <a:prstGeom prst="roundRect">
@@ -43715,7 +44401,7 @@
         </p:nvSpPr>
         <p:spPr>
           <a:xfrm>
-            <a:off x="676656" y="4673600"/>
+            <a:off x="676656" y="4606798"/>
             <a:ext cx="45720" cy="551688"/>
           </a:xfrm>
           <a:prstGeom prst="roundRect">
@@ -43761,7 +44447,7 @@
         </p:nvSpPr>
         <p:spPr>
           <a:xfrm>
-            <a:off x="877824" y="4664456"/>
+            <a:off x="877824" y="4597654"/>
             <a:ext cx="10564063" cy="624840"/>
           </a:xfrm>
           <a:prstGeom prst="rect">
@@ -43782,7 +44468,7 @@
                 </a:solidFill>
                 <a:latin typeface="Calibri"/>
               </a:rPr>
-              <a:t>The call. </a:t>
+              <a:t>The best-fit call. </a:t>
             </a:r>
             <a:r>
               <a:rPr sz="1500" b="0" i="0">
@@ -43791,24 +44477,74 @@
                 </a:solidFill>
                 <a:latin typeface="Calibri"/>
               </a:rPr>
-              <a:t>c, the only way that lets a director do all five and turns a wrong number red before it is read. What would switch it: a board pack nobody is meant to change goes as a PDF.</a:t>
-            </a:r>
-          </a:p>
-        </p:txBody>
-      </p:sp>
-      <p:sp>
-        <p:nvSpPr>
-          <p:cNvPr id="13" name="Oval 12"/>
+              <a:t>c, the only way that lets a director do all five and turns a wrong number red before it is read.</a:t>
+            </a:r>
+          </a:p>
+        </p:txBody>
+      </p:sp>
+      <p:sp>
+        <p:nvSpPr>
+          <p:cNvPr id="13" name="Rounded Rectangle 12"/>
           <p:cNvSpPr/>
           <p:nvPr/>
         </p:nvSpPr>
         <p:spPr>
           <a:xfrm>
-            <a:off x="530352" y="6492240"/>
-            <a:ext cx="64008" cy="64008"/>
-          </a:xfrm>
-          <a:prstGeom prst="ellipse">
-            <a:avLst/>
+            <a:off x="530352" y="5451093"/>
+            <a:ext cx="11130991" cy="541020"/>
+          </a:xfrm>
+          <a:prstGeom prst="roundRect">
+            <a:avLst>
+              <a:gd name="adj" fmla="val 8000"/>
+            </a:avLst>
+          </a:prstGeom>
+          <a:solidFill>
+            <a:srgbClr val="F7F5FD"/>
+          </a:solidFill>
+          <a:ln w="9525">
+            <a:solidFill>
+              <a:srgbClr val="E4E1F1"/>
+            </a:solidFill>
+          </a:ln>
+          <a:effectLst/>
+        </p:spPr>
+        <p:style>
+          <a:lnRef idx="1">
+            <a:schemeClr val="accent1"/>
+          </a:lnRef>
+          <a:fillRef idx="3">
+            <a:schemeClr val="accent1"/>
+          </a:fillRef>
+          <a:effectRef idx="2">
+            <a:schemeClr val="accent1"/>
+          </a:effectRef>
+          <a:fontRef idx="minor">
+            <a:schemeClr val="lt1"/>
+          </a:fontRef>
+        </p:style>
+        <p:txBody>
+          <a:bodyPr rtlCol="0" anchor="ctr" wrap="square"/>
+          <a:lstStyle/>
+          <a:p>
+            <a:pPr algn="ctr"/>
+          </a:p>
+        </p:txBody>
+      </p:sp>
+      <p:sp>
+        <p:nvSpPr>
+          <p:cNvPr id="14" name="Rounded Rectangle 13"/>
+          <p:cNvSpPr/>
+          <p:nvPr/>
+        </p:nvSpPr>
+        <p:spPr>
+          <a:xfrm>
+            <a:off x="676656" y="5579109"/>
+            <a:ext cx="45720" cy="284988"/>
+          </a:xfrm>
+          <a:prstGeom prst="roundRect">
+            <a:avLst>
+              <a:gd name="adj" fmla="val 50000"/>
+            </a:avLst>
           </a:prstGeom>
           <a:solidFill>
             <a:srgbClr val="5B3FD6"/>
@@ -43842,7 +44578,94 @@
       </p:sp>
       <p:sp>
         <p:nvSpPr>
-          <p:cNvPr id="14" name="TextBox 13"/>
+          <p:cNvPr id="15" name="TextBox 14"/>
+          <p:cNvSpPr txBox="1"/>
+          <p:nvPr/>
+        </p:nvSpPr>
+        <p:spPr>
+          <a:xfrm>
+            <a:off x="877824" y="5569965"/>
+            <a:ext cx="10564063" cy="358140"/>
+          </a:xfrm>
+          <a:prstGeom prst="rect">
+            <a:avLst/>
+          </a:prstGeom>
+          <a:noFill/>
+        </p:spPr>
+        <p:txBody>
+          <a:bodyPr wrap="square" anchor="ctr" lIns="0" rIns="0" tIns="0" bIns="0">
+            <a:spAutoFit/>
+          </a:bodyPr>
+          <a:lstStyle/>
+          <a:p>
+            <a:r>
+              <a:rPr sz="1500" b="1">
+                <a:solidFill>
+                  <a:srgbClr val="5B3FD6"/>
+                </a:solidFill>
+                <a:latin typeface="Calibri"/>
+              </a:rPr>
+              <a:t>The fact that would change it. </a:t>
+            </a:r>
+            <a:r>
+              <a:rPr sz="1500" b="0" i="0">
+                <a:solidFill>
+                  <a:srgbClr val="1A1440"/>
+                </a:solidFill>
+                <a:latin typeface="Calibri"/>
+              </a:rPr>
+              <a:t>A board pack nobody is meant to change goes as a PDF.</a:t>
+            </a:r>
+          </a:p>
+        </p:txBody>
+      </p:sp>
+      <p:sp>
+        <p:nvSpPr>
+          <p:cNvPr id="16" name="Oval 15"/>
+          <p:cNvSpPr/>
+          <p:nvPr/>
+        </p:nvSpPr>
+        <p:spPr>
+          <a:xfrm>
+            <a:off x="530352" y="6492240"/>
+            <a:ext cx="64008" cy="64008"/>
+          </a:xfrm>
+          <a:prstGeom prst="ellipse">
+            <a:avLst/>
+          </a:prstGeom>
+          <a:solidFill>
+            <a:srgbClr val="5B3FD6"/>
+          </a:solidFill>
+          <a:ln>
+            <a:noFill/>
+          </a:ln>
+          <a:effectLst/>
+        </p:spPr>
+        <p:style>
+          <a:lnRef idx="1">
+            <a:schemeClr val="accent1"/>
+          </a:lnRef>
+          <a:fillRef idx="3">
+            <a:schemeClr val="accent1"/>
+          </a:fillRef>
+          <a:effectRef idx="2">
+            <a:schemeClr val="accent1"/>
+          </a:effectRef>
+          <a:fontRef idx="minor">
+            <a:schemeClr val="lt1"/>
+          </a:fontRef>
+        </p:style>
+        <p:txBody>
+          <a:bodyPr rtlCol="0" anchor="ctr" wrap="square"/>
+          <a:lstStyle/>
+          <a:p>
+            <a:pPr algn="ctr"/>
+          </a:p>
+        </p:txBody>
+      </p:sp>
+      <p:sp>
+        <p:nvSpPr>
+          <p:cNvPr id="17" name="TextBox 16"/>
           <p:cNvSpPr txBox="1"/>
           <p:nvPr/>
         </p:nvSpPr>
@@ -43877,7 +44700,7 @@
       </p:sp>
       <p:sp>
         <p:nvSpPr>
-          <p:cNvPr id="15" name="Oval 14"/>
+          <p:cNvPr id="18" name="Oval 17"/>
           <p:cNvSpPr/>
           <p:nvPr/>
         </p:nvSpPr>
@@ -43921,7 +44744,7 @@
       </p:sp>
       <p:sp>
         <p:nvSpPr>
-          <p:cNvPr id="16" name="TextBox 15"/>
+          <p:cNvPr id="19" name="TextBox 18"/>
           <p:cNvSpPr txBox="1"/>
           <p:nvPr/>
         </p:nvSpPr>
@@ -43956,7 +44779,7 @@
       </p:sp>
       <p:sp>
         <p:nvSpPr>
-          <p:cNvPr id="17" name="Oval 16"/>
+          <p:cNvPr id="20" name="Oval 19"/>
           <p:cNvSpPr/>
           <p:nvPr/>
         </p:nvSpPr>
@@ -44000,7 +44823,7 @@
       </p:sp>
       <p:sp>
         <p:nvSpPr>
-          <p:cNvPr id="18" name="TextBox 17"/>
+          <p:cNvPr id="21" name="TextBox 20"/>
           <p:cNvSpPr txBox="1"/>
           <p:nvPr/>
         </p:nvSpPr>
@@ -44035,7 +44858,7 @@
       </p:sp>
       <p:sp>
         <p:nvSpPr>
-          <p:cNvPr id="19" name="Oval 18"/>
+          <p:cNvPr id="22" name="Oval 21"/>
           <p:cNvSpPr/>
           <p:nvPr/>
         </p:nvSpPr>
@@ -44079,7 +44902,7 @@
       </p:sp>
       <p:sp>
         <p:nvSpPr>
-          <p:cNvPr id="20" name="TextBox 19"/>
+          <p:cNvPr id="23" name="TextBox 22"/>
           <p:cNvSpPr txBox="1"/>
           <p:nvPr/>
         </p:nvSpPr>
@@ -44114,7 +44937,7 @@
       </p:sp>
       <p:sp>
         <p:nvSpPr>
-          <p:cNvPr id="21" name="Oval 20"/>
+          <p:cNvPr id="24" name="Oval 23"/>
           <p:cNvSpPr/>
           <p:nvPr/>
         </p:nvSpPr>
@@ -44158,7 +44981,7 @@
       </p:sp>
       <p:sp>
         <p:nvSpPr>
-          <p:cNvPr id="22" name="TextBox 21"/>
+          <p:cNvPr id="25" name="TextBox 24"/>
           <p:cNvSpPr txBox="1"/>
           <p:nvPr/>
         </p:nvSpPr>
@@ -44193,7 +45016,7 @@
       </p:sp>
       <p:sp>
         <p:nvSpPr>
-          <p:cNvPr id="23" name="Oval 22"/>
+          <p:cNvPr id="26" name="Oval 25"/>
           <p:cNvSpPr/>
           <p:nvPr/>
         </p:nvSpPr>
@@ -44237,7 +45060,7 @@
       </p:sp>
       <p:sp>
         <p:nvSpPr>
-          <p:cNvPr id="24" name="TextBox 23"/>
+          <p:cNvPr id="27" name="TextBox 26"/>
           <p:cNvSpPr txBox="1"/>
           <p:nvPr/>
         </p:nvSpPr>
@@ -44272,7 +45095,7 @@
       </p:sp>
       <p:sp>
         <p:nvSpPr>
-          <p:cNvPr id="25" name="TextBox 24"/>
+          <p:cNvPr id="28" name="TextBox 27"/>
           <p:cNvSpPr txBox="1"/>
           <p:nvPr/>
         </p:nvSpPr>
@@ -44693,7 +45516,7 @@
                 </a:solidFill>
                 <a:latin typeface="Calibri"/>
               </a:rPr>
-              <a:t>Question. </a:t>
+              <a:t>Predict before you run. </a:t>
             </a:r>
             <a:r>
               <a:rPr sz="1500" b="0" i="0">
@@ -44702,7 +45525,7 @@
                 </a:solidFill>
                 <a:latin typeface="Calibri"/>
               </a:rPr>
-              <a:t>Which changes a number's meaning with no error, as a letter?</a:t>
+              <a:t>Which changes a number's meaning with no error?</a:t>
             </a:r>
           </a:p>
         </p:txBody>
@@ -46676,7 +47499,7 @@
                 </a:solidFill>
                 <a:latin typeface="Calibri"/>
               </a:rPr>
-              <a:t>The list's foot is =SUM(E2:E51); a director filters the city column to Mumbai. What does the foot read?</a:t>
+              <a:t>When a director filters the list to Mumbai, what does a foot of =SUM(E2:E51) read?</a:t>
             </a:r>
           </a:p>
         </p:txBody>
@@ -46828,7 +47651,7 @@
                 </a:solidFill>
                 <a:latin typeface="Calibri"/>
               </a:rPr>
-              <a:t>Question. </a:t>
+              <a:t>Predict before you run. </a:t>
             </a:r>
             <a:r>
               <a:rPr sz="1500" b="0" i="0">
@@ -46837,7 +47660,7 @@
                 </a:solidFill>
                 <a:latin typeface="Calibri"/>
               </a:rPr>
-              <a:t>What does the foot read, as a letter?</a:t>
+              <a:t>What does the foot read?</a:t>
             </a:r>
           </a:p>
         </p:txBody>

</xml_diff>

<commit_message>
W02 D5 Kahoot and afternoon S30 label Thursday's 1,000 customers and 1,120 rows as Thursday's invented numbers, and the exercise index names the take-home's rehearsal copy
Co-Authored-By: Claude Opus 5.5 <noreply@anthropic.com>
Claude-Session: https://claude.ai/code/session_01Jnv4iUXDmakjfU8JHqqJa6
</commit_message>
<xml_diff>
--- a/content/W02/D5/slides/C2_W02_D05_half2_STUDENT.pptx
+++ b/content/W02/D5/slides/C2_W02_D05_half2_STUDENT.pptx
@@ -2949,12 +2949,12 @@
           <a:lstStyle/>
           <a:p>
             <a:r>
-              <a:t>LIVE, 9 minutes. Run kahoot/C2_W02_D05_quiz_STUDENT.md. The return question is Thursday's merge one level</a:t>
-            </a:r>
-          </a:p>
-          <a:p>
-            <a:r>
-              <a:t>up.</a:t>
+              <a:t>LIVE, 9 minutes. Run kahoot/C2_W02_D05_quiz_STUDENT.md. The return question is the merge from Thursday's</a:t>
+            </a:r>
+          </a:p>
+          <a:p>
+            <a:r>
+              <a:t>Kahoot, on its invented numbers, one level up.</a:t>
             </a:r>
           </a:p>
           <a:p>
@@ -39231,7 +39231,7 @@
       </p:sp>
       <p:pic>
         <p:nvPicPr>
-          <p:cNvPr id="17" name="mermaid diagram" descr="eb5525876ecd60eb.png"/>
+          <p:cNvPr id="17" name="mermaid diagram" descr="6afaaa40dbdee4fa.png"/>
           <p:cNvPicPr>
             <a:picLocks noChangeAspect="1"/>
           </p:cNvPicPr>
@@ -39245,8 +39245,8 @@
         </p:blipFill>
         <p:spPr>
           <a:xfrm>
-            <a:off x="3259778" y="3419856"/>
-            <a:ext cx="5672137" cy="1128712"/>
+            <a:off x="3159766" y="3419856"/>
+            <a:ext cx="5872162" cy="1371600"/>
           </a:xfrm>
           <a:prstGeom prst="rect">
             <a:avLst/>

</xml_diff>